<commit_message>
Update deck with accurate weights, fixes, and results; add README
</commit_message>
<xml_diff>
--- a/deck/presentation.pptx
+++ b/deck/presentation.pptx
@@ -10,6 +10,10 @@
     <p:sldId id="258" r:id="rId9"/>
     <p:sldId id="259" r:id="rId10"/>
     <p:sldId id="260" r:id="rId11"/>
+    <p:sldId id="261" r:id="rId12"/>
+    <p:sldId id="262" r:id="rId13"/>
+    <p:sldId id="263" r:id="rId14"/>
+    <p:sldId id="264" r:id="rId15"/>
   </p:sldIdLst>
   <p:sldSz cx="12191695" cy="6858000" type="screen4x3"/>
   <p:notesSz cx="6858000" cy="9144000"/>
@@ -3088,7 +3092,7 @@
     <p:bg>
       <p:bgPr>
         <a:solidFill>
-          <a:srgbClr val="1A1A2E"/>
+          <a:srgbClr val="0D1B2A"/>
         </a:solidFill>
         <a:effectLst/>
       </p:bgPr>
@@ -3102,14 +3106,57 @@
       <p:grpSpPr/>
       <p:sp>
         <p:nvSpPr>
-          <p:cNvPr id="2" name="TextBox 1"/>
+          <p:cNvPr id="2" name="Rectangle 1"/>
+          <p:cNvSpPr/>
+          <p:nvPr/>
+        </p:nvSpPr>
+        <p:spPr>
+          <a:xfrm>
+            <a:off x="0" y="2560320"/>
+            <a:ext cx="12191695" cy="54864"/>
+          </a:xfrm>
+          <a:prstGeom prst="rect">
+            <a:avLst/>
+          </a:prstGeom>
+          <a:solidFill>
+            <a:srgbClr val="0096D6"/>
+          </a:solidFill>
+          <a:ln>
+            <a:noFill/>
+          </a:ln>
+        </p:spPr>
+        <p:style>
+          <a:lnRef idx="1">
+            <a:schemeClr val="accent1"/>
+          </a:lnRef>
+          <a:fillRef idx="3">
+            <a:schemeClr val="accent1"/>
+          </a:fillRef>
+          <a:effectRef idx="2">
+            <a:schemeClr val="accent1"/>
+          </a:effectRef>
+          <a:fontRef idx="minor">
+            <a:schemeClr val="lt1"/>
+          </a:fontRef>
+        </p:style>
+        <p:txBody>
+          <a:bodyPr rtlCol="0" anchor="ctr"/>
+          <a:lstStyle/>
+          <a:p>
+            <a:pPr algn="ctr"/>
+          </a:p>
+        </p:txBody>
+      </p:sp>
+      <p:sp>
+        <p:nvSpPr>
+          <p:cNvPr id="3" name="TextBox 2"/>
           <p:cNvSpPr txBox="1"/>
           <p:nvPr/>
         </p:nvSpPr>
         <p:spPr>
           <a:xfrm>
-            <a:off x="914400" y="2286000"/>
-            <a:ext cx="10058400" cy="1828800"/>
+            <a:off x="914400" y="1371600"/>
+            <a:ext cx="10058400" cy="1097280"/>
           </a:xfrm>
           <a:prstGeom prst="rect">
             <a:avLst/>
@@ -3117,32 +3164,129 @@
           <a:noFill/>
         </p:spPr>
         <p:txBody>
-          <a:bodyPr wrap="none">
+          <a:bodyPr wrap="square">
             <a:spAutoFit/>
           </a:bodyPr>
           <a:lstStyle/>
           <a:p>
-            <a:pPr>
-              <a:defRPr sz="4400">
+            <a:pPr algn="ctr">
+              <a:defRPr sz="4400" b="1">
                 <a:solidFill>
                   <a:srgbClr val="FFFFFF"/>
                 </a:solidFill>
+                <a:latin typeface="Calibri"/>
               </a:defRPr>
             </a:pPr>
             <a:r>
               <a:t>Candidate Ranking System</a:t>
             </a:r>
           </a:p>
-          <a:p>
-            <a:pPr>
-              <a:defRPr sz="2400">
-                <a:solidFill>
-                  <a:srgbClr val="88BBFF"/>
-                </a:solidFill>
+        </p:txBody>
+      </p:sp>
+      <p:sp>
+        <p:nvSpPr>
+          <p:cNvPr id="4" name="TextBox 3"/>
+          <p:cNvSpPr txBox="1"/>
+          <p:nvPr/>
+        </p:nvSpPr>
+        <p:spPr>
+          <a:xfrm>
+            <a:off x="914400" y="2926080"/>
+            <a:ext cx="10058400" cy="548640"/>
+          </a:xfrm>
+          <a:prstGeom prst="rect">
+            <a:avLst/>
+          </a:prstGeom>
+          <a:noFill/>
+        </p:spPr>
+        <p:txBody>
+          <a:bodyPr wrap="square">
+            <a:spAutoFit/>
+          </a:bodyPr>
+          <a:lstStyle/>
+          <a:p>
+            <a:pPr algn="ctr">
+              <a:defRPr sz="2400" b="0">
+                <a:solidFill>
+                  <a:srgbClr val="0096D6"/>
+                </a:solidFill>
+                <a:latin typeface="Calibri"/>
               </a:defRPr>
             </a:pPr>
             <a:r>
               <a:t>India Runs Data &amp; AI Challenge 2026</a:t>
+            </a:r>
+          </a:p>
+        </p:txBody>
+      </p:sp>
+      <p:sp>
+        <p:nvSpPr>
+          <p:cNvPr id="5" name="TextBox 4"/>
+          <p:cNvSpPr txBox="1"/>
+          <p:nvPr/>
+        </p:nvSpPr>
+        <p:spPr>
+          <a:xfrm>
+            <a:off x="914400" y="3840480"/>
+            <a:ext cx="10058400" cy="457200"/>
+          </a:xfrm>
+          <a:prstGeom prst="rect">
+            <a:avLst/>
+          </a:prstGeom>
+          <a:noFill/>
+        </p:spPr>
+        <p:txBody>
+          <a:bodyPr wrap="square">
+            <a:spAutoFit/>
+          </a:bodyPr>
+          <a:lstStyle/>
+          <a:p>
+            <a:pPr algn="ctr">
+              <a:defRPr sz="1800" b="0">
+                <a:solidFill>
+                  <a:srgbClr val="BBBBBB"/>
+                </a:solidFill>
+                <a:latin typeface="Calibri"/>
+              </a:defRPr>
+            </a:pPr>
+            <a:r>
+              <a:t>Ranking 100K candidates against a Senior AI Engineer JD</a:t>
+            </a:r>
+          </a:p>
+        </p:txBody>
+      </p:sp>
+      <p:sp>
+        <p:nvSpPr>
+          <p:cNvPr id="6" name="TextBox 5"/>
+          <p:cNvSpPr txBox="1"/>
+          <p:nvPr/>
+        </p:nvSpPr>
+        <p:spPr>
+          <a:xfrm>
+            <a:off x="914400" y="5029200"/>
+            <a:ext cx="10058400" cy="365760"/>
+          </a:xfrm>
+          <a:prstGeom prst="rect">
+            <a:avLst/>
+          </a:prstGeom>
+          <a:noFill/>
+        </p:spPr>
+        <p:txBody>
+          <a:bodyPr wrap="square">
+            <a:spAutoFit/>
+          </a:bodyPr>
+          <a:lstStyle/>
+          <a:p>
+            <a:pPr algn="ctr">
+              <a:defRPr sz="1600" b="0">
+                <a:solidFill>
+                  <a:srgbClr val="666666"/>
+                </a:solidFill>
+                <a:latin typeface="Calibri"/>
+              </a:defRPr>
+            </a:pPr>
+            <a:r>
+              <a:t>Team: shivv23 | Solo Participant</a:t>
             </a:r>
           </a:p>
         </p:txBody>
@@ -3158,6 +3302,14 @@
 <file path=ppt/slides/slide2.xml><?xml version="1.0" encoding="utf-8"?>
 <p:sld xmlns:a="http://schemas.openxmlformats.org/drawingml/2006/main" xmlns:p="http://schemas.openxmlformats.org/presentationml/2006/main" xmlns:r="http://schemas.openxmlformats.org/officeDocument/2006/relationships">
   <p:cSld>
+    <p:bg>
+      <p:bgPr>
+        <a:solidFill>
+          <a:srgbClr val="FFFFFF"/>
+        </a:solidFill>
+        <a:effectLst/>
+      </p:bgPr>
+    </p:bg>
     <p:spTree>
       <p:nvGrpSpPr>
         <p:cNvPr id="1" name=""/>
@@ -3167,14 +3319,57 @@
       <p:grpSpPr/>
       <p:sp>
         <p:nvSpPr>
-          <p:cNvPr id="2" name="TextBox 1"/>
+          <p:cNvPr id="2" name="Rectangle 1"/>
+          <p:cNvSpPr/>
+          <p:nvPr/>
+        </p:nvSpPr>
+        <p:spPr>
+          <a:xfrm>
+            <a:off x="0" y="0"/>
+            <a:ext cx="12191695" cy="914400"/>
+          </a:xfrm>
+          <a:prstGeom prst="rect">
+            <a:avLst/>
+          </a:prstGeom>
+          <a:solidFill>
+            <a:srgbClr val="1A3C6E"/>
+          </a:solidFill>
+          <a:ln>
+            <a:noFill/>
+          </a:ln>
+        </p:spPr>
+        <p:style>
+          <a:lnRef idx="1">
+            <a:schemeClr val="accent1"/>
+          </a:lnRef>
+          <a:fillRef idx="3">
+            <a:schemeClr val="accent1"/>
+          </a:fillRef>
+          <a:effectRef idx="2">
+            <a:schemeClr val="accent1"/>
+          </a:effectRef>
+          <a:fontRef idx="minor">
+            <a:schemeClr val="lt1"/>
+          </a:fontRef>
+        </p:style>
+        <p:txBody>
+          <a:bodyPr rtlCol="0" anchor="ctr"/>
+          <a:lstStyle/>
+          <a:p>
+            <a:pPr algn="ctr"/>
+          </a:p>
+        </p:txBody>
+      </p:sp>
+      <p:sp>
+        <p:nvSpPr>
+          <p:cNvPr id="3" name="TextBox 2"/>
           <p:cNvSpPr txBox="1"/>
           <p:nvPr/>
         </p:nvSpPr>
         <p:spPr>
           <a:xfrm>
-            <a:off x="457200" y="274320"/>
-            <a:ext cx="10972800" cy="914400"/>
+            <a:off x="457200" y="182880"/>
+            <a:ext cx="10972800" cy="548640"/>
           </a:xfrm>
           <a:prstGeom prst="rect">
             <a:avLst/>
@@ -3182,109 +3377,140 @@
           <a:noFill/>
         </p:spPr>
         <p:txBody>
-          <a:bodyPr wrap="none">
+          <a:bodyPr wrap="square">
             <a:spAutoFit/>
           </a:bodyPr>
           <a:lstStyle/>
           <a:p>
+            <a:pPr algn="l">
+              <a:defRPr sz="3200" b="1">
+                <a:solidFill>
+                  <a:srgbClr val="FFFFFF"/>
+                </a:solidFill>
+                <a:latin typeface="Calibri"/>
+              </a:defRPr>
+            </a:pPr>
+            <a:r>
+              <a:t>Problem &amp; Constraints</a:t>
+            </a:r>
+          </a:p>
+        </p:txBody>
+      </p:sp>
+      <p:sp>
+        <p:nvSpPr>
+          <p:cNvPr id="4" name="TextBox 3"/>
+          <p:cNvSpPr txBox="1"/>
+          <p:nvPr/>
+        </p:nvSpPr>
+        <p:spPr>
+          <a:xfrm>
+            <a:off x="640080" y="1188720"/>
+            <a:ext cx="10515600" cy="5029200"/>
+          </a:xfrm>
+          <a:prstGeom prst="rect">
+            <a:avLst/>
+          </a:prstGeom>
+          <a:noFill/>
+        </p:spPr>
+        <p:txBody>
+          <a:bodyPr wrap="square">
+            <a:spAutoFit/>
+          </a:bodyPr>
+          <a:lstStyle/>
+          <a:p>
             <a:pPr>
-              <a:defRPr sz="2000" b="1"/>
+              <a:spcAft>
+                <a:spcPts val="600"/>
+              </a:spcAft>
+              <a:defRPr sz="1700">
+                <a:solidFill>
+                  <a:srgbClr val="333333"/>
+                </a:solidFill>
+                <a:latin typeface="Calibri"/>
+              </a:defRPr>
             </a:pPr>
             <a:r>
-              <a:t>Phase A (Precompute - offline, no time limit):</a:t>
+              <a:t>Goal: Rank 100K candidates against a Senior AI Engineer JD — output top-100</a:t>
             </a:r>
           </a:p>
           <a:p>
             <a:pPr>
-              <a:defRPr sz="1800"/>
+              <a:spcAft>
+                <a:spcPts val="600"/>
+              </a:spcAft>
+              <a:defRPr sz="1700">
+                <a:solidFill>
+                  <a:srgbClr val="333333"/>
+                </a:solidFill>
+                <a:latin typeface="Calibri"/>
+              </a:defRPr>
             </a:pPr>
             <a:r>
-              <a:t>  1. Load 100K candidates from candidates.jsonl</a:t>
+              <a:t>Scoring: 0.50×NDCG@10 + 0.30×NDCG@50 + 0.15×MAP + 0.05×P@10 — top-10 ordering is 50% of score</a:t>
             </a:r>
           </a:p>
           <a:p>
             <a:pPr>
-              <a:defRPr sz="1800"/>
+              <a:spcAft>
+                <a:spcPts val="600"/>
+              </a:spcAft>
+              <a:defRPr sz="1700">
+                <a:solidFill>
+                  <a:srgbClr val="333333"/>
+                </a:solidFill>
+                <a:latin typeface="Calibri"/>
+              </a:defRPr>
             </a:pPr>
             <a:r>
-              <a:t>  2. Extract features (title, skills, signals, education, etc.)</a:t>
+              <a:t>Phase B (ranking) must complete in ≤5 minutes on CPU, no GPU, no network calls</a:t>
             </a:r>
           </a:p>
           <a:p>
             <a:pPr>
-              <a:defRPr sz="1800"/>
+              <a:spcAft>
+                <a:spcPts val="600"/>
+              </a:spcAft>
+              <a:defRPr sz="1700">
+                <a:solidFill>
+                  <a:srgbClr val="333333"/>
+                </a:solidFill>
+                <a:latin typeface="Calibri"/>
+              </a:defRPr>
             </a:pPr>
             <a:r>
-              <a:t>  3. Embed all profiles via all-MiniLM-L6-v2 (384-dim)</a:t>
+              <a:t>Honeypot rate &gt;10% in top-100 = disqualification (~80 honeypots in dataset)</a:t>
             </a:r>
           </a:p>
           <a:p>
             <a:pPr>
-              <a:defRPr sz="1800"/>
+              <a:spcAft>
+                <a:spcPts val="600"/>
+              </a:spcAft>
+              <a:defRPr sz="1700">
+                <a:solidFill>
+                  <a:srgbClr val="333333"/>
+                </a:solidFill>
+                <a:latin typeface="Calibri"/>
+              </a:defRPr>
             </a:pPr>
             <a:r>
-              <a:t>  4. Build FAISS IndexFlatIP for semantic search</a:t>
+              <a:t>~60% of candidates (59,749) have fake/placeholder company names (Wayne Enterprises, Initech, etc.)</a:t>
             </a:r>
           </a:p>
           <a:p>
             <a:pPr>
-              <a:defRPr sz="1800"/>
+              <a:spcAft>
+                <a:spcPts val="600"/>
+              </a:spcAft>
+              <a:defRPr sz="1700">
+                <a:solidFill>
+                  <a:srgbClr val="333333"/>
+                </a:solidFill>
+                <a:latin typeface="Calibri"/>
+              </a:defRPr>
             </a:pPr>
             <a:r>
-              <a:t>  5. Pre-score all candidates on 8 dimensions</a:t>
-            </a:r>
-          </a:p>
-          <a:p>
-            <a:pPr>
-              <a:defRPr sz="1800"/>
-            </a:pPr>
-          </a:p>
-          <a:p>
-            <a:pPr>
-              <a:defRPr sz="2000" b="1"/>
-            </a:pPr>
-            <a:r>
-              <a:t>Phase B (Ranking - 5 min CPU limit, no network):</a:t>
-            </a:r>
-          </a:p>
-          <a:p>
-            <a:pPr>
-              <a:defRPr sz="1800"/>
-            </a:pPr>
-            <a:r>
-              <a:t>  1. Embed JD query using same model</a:t>
-            </a:r>
-          </a:p>
-          <a:p>
-            <a:pPr>
-              <a:defRPr sz="1800"/>
-            </a:pPr>
-            <a:r>
-              <a:t>  2. FAISS search top-2000 by cosine similarity</a:t>
-            </a:r>
-          </a:p>
-          <a:p>
-            <a:pPr>
-              <a:defRPr sz="1800"/>
-            </a:pPr>
-            <a:r>
-              <a:t>  3. Compute final score: weighted fusion of 9 dimensions</a:t>
-            </a:r>
-          </a:p>
-          <a:p>
-            <a:pPr>
-              <a:defRPr sz="1800"/>
-            </a:pPr>
-            <a:r>
-              <a:t>  4. Sort, select top-100, generate reasoning</a:t>
-            </a:r>
-          </a:p>
-          <a:p>
-            <a:pPr>
-              <a:defRPr sz="1800"/>
-            </a:pPr>
-            <a:r>
-              <a:t>  5. Output validated CSV</a:t>
+              <a:t>68.8% of candidates have non-tech titles (HR, sales, etc.) — only 10.3% have 3+ relevant ML skills</a:t>
             </a:r>
           </a:p>
         </p:txBody>
@@ -3300,6 +3526,14 @@
 <file path=ppt/slides/slide3.xml><?xml version="1.0" encoding="utf-8"?>
 <p:sld xmlns:a="http://schemas.openxmlformats.org/drawingml/2006/main" xmlns:p="http://schemas.openxmlformats.org/presentationml/2006/main" xmlns:r="http://schemas.openxmlformats.org/officeDocument/2006/relationships">
   <p:cSld>
+    <p:bg>
+      <p:bgPr>
+        <a:solidFill>
+          <a:srgbClr val="FFFFFF"/>
+        </a:solidFill>
+        <a:effectLst/>
+      </p:bgPr>
+    </p:bg>
     <p:spTree>
       <p:nvGrpSpPr>
         <p:cNvPr id="1" name=""/>
@@ -3309,14 +3543,57 @@
       <p:grpSpPr/>
       <p:sp>
         <p:nvSpPr>
-          <p:cNvPr id="2" name="TextBox 1"/>
+          <p:cNvPr id="2" name="Rectangle 1"/>
+          <p:cNvSpPr/>
+          <p:nvPr/>
+        </p:nvSpPr>
+        <p:spPr>
+          <a:xfrm>
+            <a:off x="0" y="0"/>
+            <a:ext cx="12191695" cy="914400"/>
+          </a:xfrm>
+          <a:prstGeom prst="rect">
+            <a:avLst/>
+          </a:prstGeom>
+          <a:solidFill>
+            <a:srgbClr val="1A3C6E"/>
+          </a:solidFill>
+          <a:ln>
+            <a:noFill/>
+          </a:ln>
+        </p:spPr>
+        <p:style>
+          <a:lnRef idx="1">
+            <a:schemeClr val="accent1"/>
+          </a:lnRef>
+          <a:fillRef idx="3">
+            <a:schemeClr val="accent1"/>
+          </a:fillRef>
+          <a:effectRef idx="2">
+            <a:schemeClr val="accent1"/>
+          </a:effectRef>
+          <a:fontRef idx="minor">
+            <a:schemeClr val="lt1"/>
+          </a:fontRef>
+        </p:style>
+        <p:txBody>
+          <a:bodyPr rtlCol="0" anchor="ctr"/>
+          <a:lstStyle/>
+          <a:p>
+            <a:pPr algn="ctr"/>
+          </a:p>
+        </p:txBody>
+      </p:sp>
+      <p:sp>
+        <p:nvSpPr>
+          <p:cNvPr id="3" name="TextBox 2"/>
           <p:cNvSpPr txBox="1"/>
           <p:nvPr/>
         </p:nvSpPr>
         <p:spPr>
           <a:xfrm>
-            <a:off x="457200" y="274320"/>
-            <a:ext cx="10972800" cy="914400"/>
+            <a:off x="457200" y="182880"/>
+            <a:ext cx="10972800" cy="548640"/>
           </a:xfrm>
           <a:prstGeom prst="rect">
             <a:avLst/>
@@ -3324,88 +3601,363 @@
           <a:noFill/>
         </p:spPr>
         <p:txBody>
-          <a:bodyPr wrap="none">
+          <a:bodyPr wrap="square">
             <a:spAutoFit/>
           </a:bodyPr>
           <a:lstStyle/>
           <a:p>
+            <a:pPr algn="l">
+              <a:defRPr sz="3200" b="1">
+                <a:solidFill>
+                  <a:srgbClr val="FFFFFF"/>
+                </a:solidFill>
+                <a:latin typeface="Calibri"/>
+              </a:defRPr>
+            </a:pPr>
+            <a:r>
+              <a:t>Two-Phase Pipeline Architecture</a:t>
+            </a:r>
+          </a:p>
+        </p:txBody>
+      </p:sp>
+      <p:sp>
+        <p:nvSpPr>
+          <p:cNvPr id="4" name="TextBox 3"/>
+          <p:cNvSpPr txBox="1"/>
+          <p:nvPr/>
+        </p:nvSpPr>
+        <p:spPr>
+          <a:xfrm>
+            <a:off x="640080" y="1188720"/>
+            <a:ext cx="5029200" cy="365760"/>
+          </a:xfrm>
+          <a:prstGeom prst="rect">
+            <a:avLst/>
+          </a:prstGeom>
+          <a:noFill/>
+        </p:spPr>
+        <p:txBody>
+          <a:bodyPr wrap="square">
+            <a:spAutoFit/>
+          </a:bodyPr>
+          <a:lstStyle/>
+          <a:p>
+            <a:pPr algn="l">
+              <a:defRPr sz="2000" b="1">
+                <a:solidFill>
+                  <a:srgbClr val="2D6BC4"/>
+                </a:solidFill>
+                <a:latin typeface="Calibri"/>
+              </a:defRPr>
+            </a:pPr>
+            <a:r>
+              <a:t>Phase A: Pre-computation (offline, ~14 min)</a:t>
+            </a:r>
+          </a:p>
+        </p:txBody>
+      </p:sp>
+      <p:sp>
+        <p:nvSpPr>
+          <p:cNvPr id="5" name="TextBox 4"/>
+          <p:cNvSpPr txBox="1"/>
+          <p:nvPr/>
+        </p:nvSpPr>
+        <p:spPr>
+          <a:xfrm>
+            <a:off x="640080" y="1645920"/>
+            <a:ext cx="5029200" cy="4114800"/>
+          </a:xfrm>
+          <a:prstGeom prst="rect">
+            <a:avLst/>
+          </a:prstGeom>
+          <a:noFill/>
+        </p:spPr>
+        <p:txBody>
+          <a:bodyPr wrap="square">
+            <a:spAutoFit/>
+          </a:bodyPr>
+          <a:lstStyle/>
+          <a:p>
             <a:pPr>
-              <a:defRPr sz="3200" b="1"/>
+              <a:spcAft>
+                <a:spcPts val="600"/>
+              </a:spcAft>
+              <a:defRPr sz="1500">
+                <a:solidFill>
+                  <a:srgbClr val="333333"/>
+                </a:solidFill>
+                <a:latin typeface="Calibri"/>
+              </a:defRPr>
             </a:pPr>
             <a:r>
-              <a:t>Scoring Dimensions</a:t>
+              <a:t>Load 100K candidates from candidates.jsonl</a:t>
             </a:r>
           </a:p>
           <a:p>
             <a:pPr>
-              <a:defRPr sz="1800"/>
+              <a:spcAft>
+                <a:spcPts val="600"/>
+              </a:spcAft>
+              <a:defRPr sz="1500">
+                <a:solidFill>
+                  <a:srgbClr val="333333"/>
+                </a:solidFill>
+                <a:latin typeface="Calibri"/>
+              </a:defRPr>
             </a:pPr>
             <a:r>
-              <a:t>Semantic (30%) - Profile-JD cosine similarity via all-MiniLM-L6-v2</a:t>
+              <a:t>Extract 20+ features per candidate (title, skills, company, signals, education, career history descriptions)</a:t>
             </a:r>
           </a:p>
           <a:p>
             <a:pPr>
-              <a:defRPr sz="1800"/>
+              <a:spcAft>
+                <a:spcPts val="600"/>
+              </a:spcAft>
+              <a:defRPr sz="1500">
+                <a:solidFill>
+                  <a:srgbClr val="333333"/>
+                </a:solidFill>
+                <a:latin typeface="Calibri"/>
+              </a:defRPr>
             </a:pPr>
             <a:r>
-              <a:t>Title (15%) - 35+ title variants with seniority-weighted scores</a:t>
+              <a:t>Enrich profile_text with career_history descriptions (last 3 jobs) and education</a:t>
             </a:r>
           </a:p>
           <a:p>
             <a:pPr>
-              <a:defRPr sz="1800"/>
+              <a:spcAft>
+                <a:spcPts val="600"/>
+              </a:spcAft>
+              <a:defRPr sz="1500">
+                <a:solidFill>
+                  <a:srgbClr val="333333"/>
+                </a:solidFill>
+                <a:latin typeface="Calibri"/>
+              </a:defRPr>
             </a:pPr>
             <a:r>
-              <a:t>Skills (15%) - 4 JD categories: AI/ML, retrieval, ranking, engineering</a:t>
+              <a:t>Embed all profiles via all-MiniLM-L6-v2 (384-dim, normalized)</a:t>
             </a:r>
           </a:p>
           <a:p>
             <a:pPr>
-              <a:defRPr sz="1800"/>
+              <a:spcAft>
+                <a:spcPts val="600"/>
+              </a:spcAft>
+              <a:defRPr sz="1500">
+                <a:solidFill>
+                  <a:srgbClr val="333333"/>
+                </a:solidFill>
+                <a:latin typeface="Calibri"/>
+              </a:defRPr>
             </a:pPr>
             <a:r>
-              <a:t>Experience (10%) - Bell curve centered on 7yr (target 4-10yr)</a:t>
+              <a:t>Build FAISS IndexFlatIP for inner-product (cosine) similarity search</a:t>
             </a:r>
           </a:p>
           <a:p>
             <a:pPr>
-              <a:defRPr sz="1800"/>
+              <a:spcAft>
+                <a:spcPts val="600"/>
+              </a:spcAft>
+              <a:defRPr sz="1500">
+                <a:solidFill>
+                  <a:srgbClr val="333333"/>
+                </a:solidFill>
+                <a:latin typeface="Calibri"/>
+              </a:defRPr>
             </a:pPr>
             <a:r>
-              <a:t>Signals (10%) - 9 behavioral signals: response rate, activity, etc.</a:t>
-            </a:r>
-          </a:p>
+              <a:t>Checkpoint every 5000 texts — resume after interrupt without restart</a:t>
+            </a:r>
+          </a:p>
+        </p:txBody>
+      </p:sp>
+      <p:sp>
+        <p:nvSpPr>
+          <p:cNvPr id="6" name="TextBox 5"/>
+          <p:cNvSpPr txBox="1"/>
+          <p:nvPr/>
+        </p:nvSpPr>
+        <p:spPr>
+          <a:xfrm>
+            <a:off x="6400800" y="1188720"/>
+            <a:ext cx="5029200" cy="365760"/>
+          </a:xfrm>
+          <a:prstGeom prst="rect">
+            <a:avLst/>
+          </a:prstGeom>
+          <a:noFill/>
+        </p:spPr>
+        <p:txBody>
+          <a:bodyPr wrap="square">
+            <a:spAutoFit/>
+          </a:bodyPr>
+          <a:lstStyle/>
+          <a:p>
+            <a:pPr algn="l">
+              <a:defRPr sz="2000" b="1">
+                <a:solidFill>
+                  <a:srgbClr val="2D6BC4"/>
+                </a:solidFill>
+                <a:latin typeface="Calibri"/>
+              </a:defRPr>
+            </a:pPr>
+            <a:r>
+              <a:t>Phase B: Ranking (≤5 min CPU, no network)</a:t>
+            </a:r>
+          </a:p>
+        </p:txBody>
+      </p:sp>
+      <p:sp>
+        <p:nvSpPr>
+          <p:cNvPr id="7" name="TextBox 6"/>
+          <p:cNvSpPr txBox="1"/>
+          <p:nvPr/>
+        </p:nvSpPr>
+        <p:spPr>
+          <a:xfrm>
+            <a:off x="6400800" y="1645920"/>
+            <a:ext cx="5029200" cy="4114800"/>
+          </a:xfrm>
+          <a:prstGeom prst="rect">
+            <a:avLst/>
+          </a:prstGeom>
+          <a:noFill/>
+        </p:spPr>
+        <p:txBody>
+          <a:bodyPr wrap="square">
+            <a:spAutoFit/>
+          </a:bodyPr>
+          <a:lstStyle/>
           <a:p>
             <a:pPr>
-              <a:defRPr sz="1800"/>
+              <a:spcAft>
+                <a:spcPts val="600"/>
+              </a:spcAft>
+              <a:defRPr sz="1500">
+                <a:solidFill>
+                  <a:srgbClr val="333333"/>
+                </a:solidFill>
+                <a:latin typeface="Calibri"/>
+              </a:defRPr>
             </a:pPr>
             <a:r>
-              <a:t>Company (5%) - Product=1.0, Startup=0.6, Consulting=0.4</a:t>
+              <a:t>Embed JD query using same sentence-transformer model</a:t>
             </a:r>
           </a:p>
           <a:p>
             <a:pPr>
-              <a:defRPr sz="1800"/>
+              <a:spcAft>
+                <a:spcPts val="600"/>
+              </a:spcAft>
+              <a:defRPr sz="1500">
+                <a:solidFill>
+                  <a:srgbClr val="333333"/>
+                </a:solidFill>
+                <a:latin typeface="Calibri"/>
+              </a:defRPr>
             </a:pPr>
             <a:r>
-              <a:t>Location (5%) - Preferred cities 1.0, India 0.7, Intl 0.4</a:t>
+              <a:t>FAISS search: retrieve top-10K candidates by cosine similarity</a:t>
             </a:r>
           </a:p>
           <a:p>
             <a:pPr>
-              <a:defRPr sz="1800"/>
+              <a:spcAft>
+                <a:spcPts val="600"/>
+              </a:spcAft>
+              <a:defRPr sz="1500">
+                <a:solidFill>
+                  <a:srgbClr val="333333"/>
+                </a:solidFill>
+                <a:latin typeface="Calibri"/>
+              </a:defRPr>
             </a:pPr>
             <a:r>
-              <a:t>Education (5%) - CS/AI/ML/related fields 1.0, else 0.5</a:t>
+              <a:t>Min-max normalize semantic scores within top-1000 for discriminability</a:t>
             </a:r>
           </a:p>
           <a:p>
             <a:pPr>
-              <a:defRPr sz="1800"/>
+              <a:spcAft>
+                <a:spcPts val="600"/>
+              </a:spcAft>
+              <a:defRPr sz="1500">
+                <a:solidFill>
+                  <a:srgbClr val="333333"/>
+                </a:solidFill>
+                <a:latin typeface="Calibri"/>
+              </a:defRPr>
             </a:pPr>
             <a:r>
-              <a:t>Honeypot Mod. (5%) - Multiplicative penalty: stuffing, ghost, inactive</a:t>
+              <a:t>Fuse 8 scoring dimensions (weighted linear combination)</a:t>
+            </a:r>
+          </a:p>
+          <a:p>
+            <a:pPr>
+              <a:spcAft>
+                <a:spcPts val="600"/>
+              </a:spcAft>
+              <a:defRPr sz="1500">
+                <a:solidFill>
+                  <a:srgbClr val="333333"/>
+                </a:solidFill>
+                <a:latin typeface="Calibri"/>
+              </a:defRPr>
+            </a:pPr>
+            <a:r>
+              <a:t>Apply modifiers: honeypot penalty, notice period, score spread</a:t>
+            </a:r>
+          </a:p>
+          <a:p>
+            <a:pPr>
+              <a:spcAft>
+                <a:spcPts val="600"/>
+              </a:spcAft>
+              <a:defRPr sz="1500">
+                <a:solidFill>
+                  <a:srgbClr val="333333"/>
+                </a:solidFill>
+                <a:latin typeface="Calibri"/>
+              </a:defRPr>
+            </a:pPr>
+            <a:r>
+              <a:t>Sort by score desc (4-decimal tie-breaking by candidate_id ascending)</a:t>
+            </a:r>
+          </a:p>
+          <a:p>
+            <a:pPr>
+              <a:spcAft>
+                <a:spcPts val="600"/>
+              </a:spcAft>
+              <a:defRPr sz="1500">
+                <a:solidFill>
+                  <a:srgbClr val="333333"/>
+                </a:solidFill>
+                <a:latin typeface="Calibri"/>
+              </a:defRPr>
+            </a:pPr>
+            <a:r>
+              <a:t>Generate 3-tier reasoning (rank-dependent verbosity)</a:t>
+            </a:r>
+          </a:p>
+          <a:p>
+            <a:pPr>
+              <a:spcAft>
+                <a:spcPts val="600"/>
+              </a:spcAft>
+              <a:defRPr sz="1500">
+                <a:solidFill>
+                  <a:srgbClr val="333333"/>
+                </a:solidFill>
+                <a:latin typeface="Calibri"/>
+              </a:defRPr>
+            </a:pPr>
+            <a:r>
+              <a:t>Output validated CSV: 100 rows, non-increasing scores</a:t>
             </a:r>
           </a:p>
         </p:txBody>
@@ -3421,6 +3973,14 @@
 <file path=ppt/slides/slide4.xml><?xml version="1.0" encoding="utf-8"?>
 <p:sld xmlns:a="http://schemas.openxmlformats.org/drawingml/2006/main" xmlns:p="http://schemas.openxmlformats.org/presentationml/2006/main" xmlns:r="http://schemas.openxmlformats.org/officeDocument/2006/relationships">
   <p:cSld>
+    <p:bg>
+      <p:bgPr>
+        <a:solidFill>
+          <a:srgbClr val="FFFFFF"/>
+        </a:solidFill>
+        <a:effectLst/>
+      </p:bgPr>
+    </p:bg>
     <p:spTree>
       <p:nvGrpSpPr>
         <p:cNvPr id="1" name=""/>
@@ -3430,14 +3990,57 @@
       <p:grpSpPr/>
       <p:sp>
         <p:nvSpPr>
-          <p:cNvPr id="2" name="TextBox 1"/>
+          <p:cNvPr id="2" name="Rectangle 1"/>
+          <p:cNvSpPr/>
+          <p:nvPr/>
+        </p:nvSpPr>
+        <p:spPr>
+          <a:xfrm>
+            <a:off x="0" y="0"/>
+            <a:ext cx="12191695" cy="914400"/>
+          </a:xfrm>
+          <a:prstGeom prst="rect">
+            <a:avLst/>
+          </a:prstGeom>
+          <a:solidFill>
+            <a:srgbClr val="1A3C6E"/>
+          </a:solidFill>
+          <a:ln>
+            <a:noFill/>
+          </a:ln>
+        </p:spPr>
+        <p:style>
+          <a:lnRef idx="1">
+            <a:schemeClr val="accent1"/>
+          </a:lnRef>
+          <a:fillRef idx="3">
+            <a:schemeClr val="accent1"/>
+          </a:fillRef>
+          <a:effectRef idx="2">
+            <a:schemeClr val="accent1"/>
+          </a:effectRef>
+          <a:fontRef idx="minor">
+            <a:schemeClr val="lt1"/>
+          </a:fontRef>
+        </p:style>
+        <p:txBody>
+          <a:bodyPr rtlCol="0" anchor="ctr"/>
+          <a:lstStyle/>
+          <a:p>
+            <a:pPr algn="ctr"/>
+          </a:p>
+        </p:txBody>
+      </p:sp>
+      <p:sp>
+        <p:nvSpPr>
+          <p:cNvPr id="3" name="TextBox 2"/>
           <p:cNvSpPr txBox="1"/>
           <p:nvPr/>
         </p:nvSpPr>
         <p:spPr>
           <a:xfrm>
-            <a:off x="457200" y="274320"/>
-            <a:ext cx="10972800" cy="914400"/>
+            <a:off x="457200" y="182880"/>
+            <a:ext cx="10972800" cy="548640"/>
           </a:xfrm>
           <a:prstGeom prst="rect">
             <a:avLst/>
@@ -3445,73 +4048,789 @@
           <a:noFill/>
         </p:spPr>
         <p:txBody>
-          <a:bodyPr wrap="none">
+          <a:bodyPr wrap="square">
             <a:spAutoFit/>
           </a:bodyPr>
           <a:lstStyle/>
           <a:p>
-            <a:pPr>
-              <a:defRPr sz="3200" b="1"/>
+            <a:pPr algn="l">
+              <a:defRPr sz="3200" b="1">
+                <a:solidFill>
+                  <a:srgbClr val="FFFFFF"/>
+                </a:solidFill>
+                <a:latin typeface="Calibri"/>
+              </a:defRPr>
             </a:pPr>
             <a:r>
-              <a:t>Honeypot Detection</a:t>
-            </a:r>
-          </a:p>
-          <a:p>
-            <a:pPr>
-              <a:defRPr sz="1800"/>
-            </a:pPr>
-            <a:r>
-              <a:t>1. Keyword stuffing: non-tech title + excessive skill count</a:t>
-            </a:r>
-          </a:p>
-          <a:p>
-            <a:pPr>
-              <a:defRPr sz="1800"/>
-            </a:pPr>
-            <a:r>
-              <a:t>2. AI skill stuffing: non-tech title + 8+ AI keywords</a:t>
-            </a:r>
-          </a:p>
-          <a:p>
-            <a:pPr>
-              <a:defRPr sz="1800"/>
-            </a:pPr>
-            <a:r>
-              <a:t>3. Impossible breadth: 18+ skills (can't be expert in all)</a:t>
-            </a:r>
-          </a:p>
-          <a:p>
-            <a:pPr>
-              <a:defRPr sz="1800"/>
-            </a:pPr>
-            <a:r>
-              <a:t>4. Ghost profile: low response rate + high profile views</a:t>
-            </a:r>
-          </a:p>
-          <a:p>
-            <a:pPr>
-              <a:defRPr sz="1800"/>
-            </a:pPr>
-            <a:r>
-              <a:t>5. Inactive: 200+ days inactive + not open to work</a:t>
-            </a:r>
-          </a:p>
-          <a:p>
-            <a:pPr>
-              <a:defRPr sz="1800"/>
-            </a:pPr>
-          </a:p>
-          <a:p>
-            <a:pPr>
-              <a:defRPr sz="1800"/>
-            </a:pPr>
-            <a:r>
-              <a:t>Result: 0 honeypots in top 100 (0% - well under 10% limit)</a:t>
-            </a:r>
-          </a:p>
-        </p:txBody>
-      </p:sp>
+              <a:t>Scoring Dimensions (Weighted Fusion)</a:t>
+            </a:r>
+          </a:p>
+        </p:txBody>
+      </p:sp>
+      <p:graphicFrame>
+        <p:nvGraphicFramePr>
+          <p:cNvPr id="4" name="Table 3"/>
+          <p:cNvGraphicFramePr>
+            <a:graphicFrameLocks noGrp="1"/>
+          </p:cNvGraphicFramePr>
+          <p:nvPr/>
+        </p:nvGraphicFramePr>
+        <p:xfrm>
+          <a:off x="1371600" y="1188720"/>
+          <a:ext cx="9144000" cy="5029200"/>
+        </p:xfrm>
+        <a:graphic>
+          <a:graphicData uri="http://schemas.openxmlformats.org/drawingml/2006/table">
+            <a:tbl>
+              <a:tblPr firstRow="1" bandRow="1">
+                <a:tableStyleId>{5C22544A-7EE6-4342-B048-85BDC9FD1C3A}</a:tableStyleId>
+              </a:tblPr>
+              <a:tblGrid>
+                <a:gridCol w="1828800"/>
+                <a:gridCol w="1371600"/>
+                <a:gridCol w="5943600"/>
+              </a:tblGrid>
+              <a:tr h="502920">
+                <a:tc>
+                  <a:txBody>
+                    <a:bodyPr/>
+                    <a:lstStyle/>
+                    <a:p>
+                      <a:pPr algn="ctr">
+                        <a:defRPr sz="1400" b="1">
+                          <a:solidFill>
+                            <a:srgbClr val="FFFFFF"/>
+                          </a:solidFill>
+                        </a:defRPr>
+                      </a:pPr>
+                      <a:r>
+                        <a:t>Dimension</a:t>
+                      </a:r>
+                    </a:p>
+                  </a:txBody>
+                  <a:tcPr>
+                    <a:solidFill>
+                      <a:srgbClr val="1A3C6E"/>
+                    </a:solidFill>
+                  </a:tcPr>
+                </a:tc>
+                <a:tc>
+                  <a:txBody>
+                    <a:bodyPr/>
+                    <a:lstStyle/>
+                    <a:p>
+                      <a:pPr algn="ctr">
+                        <a:defRPr sz="1400" b="1">
+                          <a:solidFill>
+                            <a:srgbClr val="FFFFFF"/>
+                          </a:solidFill>
+                        </a:defRPr>
+                      </a:pPr>
+                      <a:r>
+                        <a:t>Weight</a:t>
+                      </a:r>
+                    </a:p>
+                  </a:txBody>
+                  <a:tcPr>
+                    <a:solidFill>
+                      <a:srgbClr val="1A3C6E"/>
+                    </a:solidFill>
+                  </a:tcPr>
+                </a:tc>
+                <a:tc>
+                  <a:txBody>
+                    <a:bodyPr/>
+                    <a:lstStyle/>
+                    <a:p>
+                      <a:pPr algn="ctr">
+                        <a:defRPr sz="1400" b="1">
+                          <a:solidFill>
+                            <a:srgbClr val="FFFFFF"/>
+                          </a:solidFill>
+                        </a:defRPr>
+                      </a:pPr>
+                      <a:r>
+                        <a:t>Description</a:t>
+                      </a:r>
+                    </a:p>
+                  </a:txBody>
+                  <a:tcPr>
+                    <a:solidFill>
+                      <a:srgbClr val="1A3C6E"/>
+                    </a:solidFill>
+                  </a:tcPr>
+                </a:tc>
+              </a:tr>
+              <a:tr h="502920">
+                <a:tc>
+                  <a:txBody>
+                    <a:bodyPr/>
+                    <a:lstStyle/>
+                    <a:p>
+                      <a:pPr>
+                        <a:defRPr sz="1300">
+                          <a:solidFill>
+                            <a:srgbClr val="333333"/>
+                          </a:solidFill>
+                          <a:latin typeface="Calibri"/>
+                        </a:defRPr>
+                      </a:pPr>
+                      <a:r>
+                        <a:t>Semantic</a:t>
+                      </a:r>
+                    </a:p>
+                  </a:txBody>
+                  <a:tcPr>
+                    <a:solidFill>
+                      <a:srgbClr val="F0F4F8"/>
+                    </a:solidFill>
+                  </a:tcPr>
+                </a:tc>
+                <a:tc>
+                  <a:txBody>
+                    <a:bodyPr/>
+                    <a:lstStyle/>
+                    <a:p>
+                      <a:pPr>
+                        <a:defRPr sz="1300">
+                          <a:solidFill>
+                            <a:srgbClr val="333333"/>
+                          </a:solidFill>
+                          <a:latin typeface="Calibri"/>
+                        </a:defRPr>
+                      </a:pPr>
+                      <a:r>
+                        <a:t>20%</a:t>
+                      </a:r>
+                    </a:p>
+                  </a:txBody>
+                  <a:tcPr>
+                    <a:solidFill>
+                      <a:srgbClr val="F0F4F8"/>
+                    </a:solidFill>
+                  </a:tcPr>
+                </a:tc>
+                <a:tc>
+                  <a:txBody>
+                    <a:bodyPr/>
+                    <a:lstStyle/>
+                    <a:p>
+                      <a:pPr>
+                        <a:defRPr sz="1300">
+                          <a:solidFill>
+                            <a:srgbClr val="333333"/>
+                          </a:solidFill>
+                          <a:latin typeface="Calibri"/>
+                        </a:defRPr>
+                      </a:pPr>
+                      <a:r>
+                        <a:t>Profile-JD cosine similarity via all-MiniLM-L6-v2 embedding</a:t>
+                      </a:r>
+                    </a:p>
+                  </a:txBody>
+                  <a:tcPr>
+                    <a:solidFill>
+                      <a:srgbClr val="F0F4F8"/>
+                    </a:solidFill>
+                  </a:tcPr>
+                </a:tc>
+              </a:tr>
+              <a:tr h="502920">
+                <a:tc>
+                  <a:txBody>
+                    <a:bodyPr/>
+                    <a:lstStyle/>
+                    <a:p>
+                      <a:pPr>
+                        <a:defRPr sz="1300">
+                          <a:solidFill>
+                            <a:srgbClr val="333333"/>
+                          </a:solidFill>
+                          <a:latin typeface="Calibri"/>
+                        </a:defRPr>
+                      </a:pPr>
+                      <a:r>
+                        <a:t>Skills</a:t>
+                      </a:r>
+                    </a:p>
+                  </a:txBody>
+                  <a:tcPr>
+                    <a:solidFill>
+                      <a:srgbClr val="FFFFFF"/>
+                    </a:solidFill>
+                  </a:tcPr>
+                </a:tc>
+                <a:tc>
+                  <a:txBody>
+                    <a:bodyPr/>
+                    <a:lstStyle/>
+                    <a:p>
+                      <a:pPr>
+                        <a:defRPr sz="1300">
+                          <a:solidFill>
+                            <a:srgbClr val="333333"/>
+                          </a:solidFill>
+                          <a:latin typeface="Calibri"/>
+                        </a:defRPr>
+                      </a:pPr>
+                      <a:r>
+                        <a:t>30%</a:t>
+                      </a:r>
+                    </a:p>
+                  </a:txBody>
+                  <a:tcPr>
+                    <a:solidFill>
+                      <a:srgbClr val="FFFFFF"/>
+                    </a:solidFill>
+                  </a:tcPr>
+                </a:tc>
+                <a:tc>
+                  <a:txBody>
+                    <a:bodyPr/>
+                    <a:lstStyle/>
+                    <a:p>
+                      <a:pPr>
+                        <a:defRPr sz="1300">
+                          <a:solidFill>
+                            <a:srgbClr val="333333"/>
+                          </a:solidFill>
+                          <a:latin typeface="Calibri"/>
+                        </a:defRPr>
+                      </a:pPr>
+                      <a:r>
+                        <a:t>4 JD categories: AI/ML, retrieval, ranking, engineering — capped per category</a:t>
+                      </a:r>
+                    </a:p>
+                  </a:txBody>
+                  <a:tcPr>
+                    <a:solidFill>
+                      <a:srgbClr val="FFFFFF"/>
+                    </a:solidFill>
+                  </a:tcPr>
+                </a:tc>
+              </a:tr>
+              <a:tr h="502920">
+                <a:tc>
+                  <a:txBody>
+                    <a:bodyPr/>
+                    <a:lstStyle/>
+                    <a:p>
+                      <a:pPr>
+                        <a:defRPr sz="1300">
+                          <a:solidFill>
+                            <a:srgbClr val="333333"/>
+                          </a:solidFill>
+                          <a:latin typeface="Calibri"/>
+                        </a:defRPr>
+                      </a:pPr>
+                      <a:r>
+                        <a:t>Title</a:t>
+                      </a:r>
+                    </a:p>
+                  </a:txBody>
+                  <a:tcPr>
+                    <a:solidFill>
+                      <a:srgbClr val="F0F4F8"/>
+                    </a:solidFill>
+                  </a:tcPr>
+                </a:tc>
+                <a:tc>
+                  <a:txBody>
+                    <a:bodyPr/>
+                    <a:lstStyle/>
+                    <a:p>
+                      <a:pPr>
+                        <a:defRPr sz="1300">
+                          <a:solidFill>
+                            <a:srgbClr val="333333"/>
+                          </a:solidFill>
+                          <a:latin typeface="Calibri"/>
+                        </a:defRPr>
+                      </a:pPr>
+                      <a:r>
+                        <a:t>15%</a:t>
+                      </a:r>
+                    </a:p>
+                  </a:txBody>
+                  <a:tcPr>
+                    <a:solidFill>
+                      <a:srgbClr val="F0F4F8"/>
+                    </a:solidFill>
+                  </a:tcPr>
+                </a:tc>
+                <a:tc>
+                  <a:txBody>
+                    <a:bodyPr/>
+                    <a:lstStyle/>
+                    <a:p>
+                      <a:pPr>
+                        <a:defRPr sz="1300">
+                          <a:solidFill>
+                            <a:srgbClr val="333333"/>
+                          </a:solidFill>
+                          <a:latin typeface="Calibri"/>
+                        </a:defRPr>
+                      </a:pPr>
+                      <a:r>
+                        <a:t>35+ title variants with seniority-weighted scores (0.20–1.0)</a:t>
+                      </a:r>
+                    </a:p>
+                  </a:txBody>
+                  <a:tcPr>
+                    <a:solidFill>
+                      <a:srgbClr val="F0F4F8"/>
+                    </a:solidFill>
+                  </a:tcPr>
+                </a:tc>
+              </a:tr>
+              <a:tr h="502920">
+                <a:tc>
+                  <a:txBody>
+                    <a:bodyPr/>
+                    <a:lstStyle/>
+                    <a:p>
+                      <a:pPr>
+                        <a:defRPr sz="1300">
+                          <a:solidFill>
+                            <a:srgbClr val="333333"/>
+                          </a:solidFill>
+                          <a:latin typeface="Calibri"/>
+                        </a:defRPr>
+                      </a:pPr>
+                      <a:r>
+                        <a:t>Experience</a:t>
+                      </a:r>
+                    </a:p>
+                  </a:txBody>
+                  <a:tcPr>
+                    <a:solidFill>
+                      <a:srgbClr val="FFFFFF"/>
+                    </a:solidFill>
+                  </a:tcPr>
+                </a:tc>
+                <a:tc>
+                  <a:txBody>
+                    <a:bodyPr/>
+                    <a:lstStyle/>
+                    <a:p>
+                      <a:pPr>
+                        <a:defRPr sz="1300">
+                          <a:solidFill>
+                            <a:srgbClr val="333333"/>
+                          </a:solidFill>
+                          <a:latin typeface="Calibri"/>
+                        </a:defRPr>
+                      </a:pPr>
+                      <a:r>
+                        <a:t>10%</a:t>
+                      </a:r>
+                    </a:p>
+                  </a:txBody>
+                  <a:tcPr>
+                    <a:solidFill>
+                      <a:srgbClr val="FFFFFF"/>
+                    </a:solidFill>
+                  </a:tcPr>
+                </a:tc>
+                <a:tc>
+                  <a:txBody>
+                    <a:bodyPr/>
+                    <a:lstStyle/>
+                    <a:p>
+                      <a:pPr>
+                        <a:defRPr sz="1300">
+                          <a:solidFill>
+                            <a:srgbClr val="333333"/>
+                          </a:solidFill>
+                          <a:latin typeface="Calibri"/>
+                        </a:defRPr>
+                      </a:pPr>
+                      <a:r>
+                        <a:t>Bell curve centered on 7yr (target 4–10yr), penalty outside range</a:t>
+                      </a:r>
+                    </a:p>
+                  </a:txBody>
+                  <a:tcPr>
+                    <a:solidFill>
+                      <a:srgbClr val="FFFFFF"/>
+                    </a:solidFill>
+                  </a:tcPr>
+                </a:tc>
+              </a:tr>
+              <a:tr h="502920">
+                <a:tc>
+                  <a:txBody>
+                    <a:bodyPr/>
+                    <a:lstStyle/>
+                    <a:p>
+                      <a:pPr>
+                        <a:defRPr sz="1300">
+                          <a:solidFill>
+                            <a:srgbClr val="333333"/>
+                          </a:solidFill>
+                          <a:latin typeface="Calibri"/>
+                        </a:defRPr>
+                      </a:pPr>
+                      <a:r>
+                        <a:t>Signals</a:t>
+                      </a:r>
+                    </a:p>
+                  </a:txBody>
+                  <a:tcPr>
+                    <a:solidFill>
+                      <a:srgbClr val="F0F4F8"/>
+                    </a:solidFill>
+                  </a:tcPr>
+                </a:tc>
+                <a:tc>
+                  <a:txBody>
+                    <a:bodyPr/>
+                    <a:lstStyle/>
+                    <a:p>
+                      <a:pPr>
+                        <a:defRPr sz="1300">
+                          <a:solidFill>
+                            <a:srgbClr val="333333"/>
+                          </a:solidFill>
+                          <a:latin typeface="Calibri"/>
+                        </a:defRPr>
+                      </a:pPr>
+                      <a:r>
+                        <a:t>10%</a:t>
+                      </a:r>
+                    </a:p>
+                  </a:txBody>
+                  <a:tcPr>
+                    <a:solidFill>
+                      <a:srgbClr val="F0F4F8"/>
+                    </a:solidFill>
+                  </a:tcPr>
+                </a:tc>
+                <a:tc>
+                  <a:txBody>
+                    <a:bodyPr/>
+                    <a:lstStyle/>
+                    <a:p>
+                      <a:pPr>
+                        <a:defRPr sz="1300">
+                          <a:solidFill>
+                            <a:srgbClr val="333333"/>
+                          </a:solidFill>
+                          <a:latin typeface="Calibri"/>
+                        </a:defRPr>
+                      </a:pPr>
+                      <a:r>
+                        <a:t>9 behavioral signals: response rate, activity, open-to-work, GitHub, etc.</a:t>
+                      </a:r>
+                    </a:p>
+                  </a:txBody>
+                  <a:tcPr>
+                    <a:solidFill>
+                      <a:srgbClr val="F0F4F8"/>
+                    </a:solidFill>
+                  </a:tcPr>
+                </a:tc>
+              </a:tr>
+              <a:tr h="502920">
+                <a:tc>
+                  <a:txBody>
+                    <a:bodyPr/>
+                    <a:lstStyle/>
+                    <a:p>
+                      <a:pPr>
+                        <a:defRPr sz="1300">
+                          <a:solidFill>
+                            <a:srgbClr val="333333"/>
+                          </a:solidFill>
+                          <a:latin typeface="Calibri"/>
+                        </a:defRPr>
+                      </a:pPr>
+                      <a:r>
+                        <a:t>Company</a:t>
+                      </a:r>
+                    </a:p>
+                  </a:txBody>
+                  <a:tcPr>
+                    <a:solidFill>
+                      <a:srgbClr val="FFFFFF"/>
+                    </a:solidFill>
+                  </a:tcPr>
+                </a:tc>
+                <a:tc>
+                  <a:txBody>
+                    <a:bodyPr/>
+                    <a:lstStyle/>
+                    <a:p>
+                      <a:pPr>
+                        <a:defRPr sz="1300">
+                          <a:solidFill>
+                            <a:srgbClr val="333333"/>
+                          </a:solidFill>
+                          <a:latin typeface="Calibri"/>
+                        </a:defRPr>
+                      </a:pPr>
+                      <a:r>
+                        <a:t>5%</a:t>
+                      </a:r>
+                    </a:p>
+                  </a:txBody>
+                  <a:tcPr>
+                    <a:solidFill>
+                      <a:srgbClr val="FFFFFF"/>
+                    </a:solidFill>
+                  </a:tcPr>
+                </a:tc>
+                <a:tc>
+                  <a:txBody>
+                    <a:bodyPr/>
+                    <a:lstStyle/>
+                    <a:p>
+                      <a:pPr>
+                        <a:defRPr sz="1300">
+                          <a:solidFill>
+                            <a:srgbClr val="333333"/>
+                          </a:solidFill>
+                          <a:latin typeface="Calibri"/>
+                        </a:defRPr>
+                      </a:pPr>
+                      <a:r>
+                        <a:t>Product=1.0, Startup=0.6, Consulting=0.4</a:t>
+                      </a:r>
+                    </a:p>
+                  </a:txBody>
+                  <a:tcPr>
+                    <a:solidFill>
+                      <a:srgbClr val="FFFFFF"/>
+                    </a:solidFill>
+                  </a:tcPr>
+                </a:tc>
+              </a:tr>
+              <a:tr h="502920">
+                <a:tc>
+                  <a:txBody>
+                    <a:bodyPr/>
+                    <a:lstStyle/>
+                    <a:p>
+                      <a:pPr>
+                        <a:defRPr sz="1300">
+                          <a:solidFill>
+                            <a:srgbClr val="333333"/>
+                          </a:solidFill>
+                          <a:latin typeface="Calibri"/>
+                        </a:defRPr>
+                      </a:pPr>
+                      <a:r>
+                        <a:t>Location</a:t>
+                      </a:r>
+                    </a:p>
+                  </a:txBody>
+                  <a:tcPr>
+                    <a:solidFill>
+                      <a:srgbClr val="F0F4F8"/>
+                    </a:solidFill>
+                  </a:tcPr>
+                </a:tc>
+                <a:tc>
+                  <a:txBody>
+                    <a:bodyPr/>
+                    <a:lstStyle/>
+                    <a:p>
+                      <a:pPr>
+                        <a:defRPr sz="1300">
+                          <a:solidFill>
+                            <a:srgbClr val="333333"/>
+                          </a:solidFill>
+                          <a:latin typeface="Calibri"/>
+                        </a:defRPr>
+                      </a:pPr>
+                      <a:r>
+                        <a:t>5%</a:t>
+                      </a:r>
+                    </a:p>
+                  </a:txBody>
+                  <a:tcPr>
+                    <a:solidFill>
+                      <a:srgbClr val="F0F4F8"/>
+                    </a:solidFill>
+                  </a:tcPr>
+                </a:tc>
+                <a:tc>
+                  <a:txBody>
+                    <a:bodyPr/>
+                    <a:lstStyle/>
+                    <a:p>
+                      <a:pPr>
+                        <a:defRPr sz="1300">
+                          <a:solidFill>
+                            <a:srgbClr val="333333"/>
+                          </a:solidFill>
+                          <a:latin typeface="Calibri"/>
+                        </a:defRPr>
+                      </a:pPr>
+                      <a:r>
+                        <a:t>Pune/Noida or willing-to-relocate=1.0, other India=0.7, intl=0.4</a:t>
+                      </a:r>
+                    </a:p>
+                  </a:txBody>
+                  <a:tcPr>
+                    <a:solidFill>
+                      <a:srgbClr val="F0F4F8"/>
+                    </a:solidFill>
+                  </a:tcPr>
+                </a:tc>
+              </a:tr>
+              <a:tr h="502920">
+                <a:tc>
+                  <a:txBody>
+                    <a:bodyPr/>
+                    <a:lstStyle/>
+                    <a:p>
+                      <a:pPr>
+                        <a:defRPr sz="1300">
+                          <a:solidFill>
+                            <a:srgbClr val="333333"/>
+                          </a:solidFill>
+                          <a:latin typeface="Calibri"/>
+                        </a:defRPr>
+                      </a:pPr>
+                      <a:r>
+                        <a:t>Education</a:t>
+                      </a:r>
+                    </a:p>
+                  </a:txBody>
+                  <a:tcPr>
+                    <a:solidFill>
+                      <a:srgbClr val="FFFFFF"/>
+                    </a:solidFill>
+                  </a:tcPr>
+                </a:tc>
+                <a:tc>
+                  <a:txBody>
+                    <a:bodyPr/>
+                    <a:lstStyle/>
+                    <a:p>
+                      <a:pPr>
+                        <a:defRPr sz="1300">
+                          <a:solidFill>
+                            <a:srgbClr val="333333"/>
+                          </a:solidFill>
+                          <a:latin typeface="Calibri"/>
+                        </a:defRPr>
+                      </a:pPr>
+                      <a:r>
+                        <a:t>5%</a:t>
+                      </a:r>
+                    </a:p>
+                  </a:txBody>
+                  <a:tcPr>
+                    <a:solidFill>
+                      <a:srgbClr val="FFFFFF"/>
+                    </a:solidFill>
+                  </a:tcPr>
+                </a:tc>
+                <a:tc>
+                  <a:txBody>
+                    <a:bodyPr/>
+                    <a:lstStyle/>
+                    <a:p>
+                      <a:pPr>
+                        <a:defRPr sz="1300">
+                          <a:solidFill>
+                            <a:srgbClr val="333333"/>
+                          </a:solidFill>
+                          <a:latin typeface="Calibri"/>
+                        </a:defRPr>
+                      </a:pPr>
+                      <a:r>
+                        <a:t>CS/AI/ML/related fields=1.0, else=0.5</a:t>
+                      </a:r>
+                    </a:p>
+                  </a:txBody>
+                  <a:tcPr>
+                    <a:solidFill>
+                      <a:srgbClr val="FFFFFF"/>
+                    </a:solidFill>
+                  </a:tcPr>
+                </a:tc>
+              </a:tr>
+              <a:tr h="502920">
+                <a:tc>
+                  <a:txBody>
+                    <a:bodyPr/>
+                    <a:lstStyle/>
+                    <a:p>
+                      <a:pPr>
+                        <a:defRPr sz="1300">
+                          <a:solidFill>
+                            <a:srgbClr val="333333"/>
+                          </a:solidFill>
+                          <a:latin typeface="Calibri"/>
+                        </a:defRPr>
+                      </a:pPr>
+                      <a:r>
+                        <a:t>Honeypot</a:t>
+                      </a:r>
+                    </a:p>
+                  </a:txBody>
+                  <a:tcPr>
+                    <a:solidFill>
+                      <a:srgbClr val="F0F4F8"/>
+                    </a:solidFill>
+                  </a:tcPr>
+                </a:tc>
+                <a:tc>
+                  <a:txBody>
+                    <a:bodyPr/>
+                    <a:lstStyle/>
+                    <a:p>
+                      <a:pPr>
+                        <a:defRPr sz="1300">
+                          <a:solidFill>
+                            <a:srgbClr val="333333"/>
+                          </a:solidFill>
+                          <a:latin typeface="Calibri"/>
+                        </a:defRPr>
+                      </a:pPr>
+                      <a:r>
+                        <a:t>Modifier</a:t>
+                      </a:r>
+                    </a:p>
+                  </a:txBody>
+                  <a:tcPr>
+                    <a:solidFill>
+                      <a:srgbClr val="F0F4F8"/>
+                    </a:solidFill>
+                  </a:tcPr>
+                </a:tc>
+                <a:tc>
+                  <a:txBody>
+                    <a:bodyPr/>
+                    <a:lstStyle/>
+                    <a:p>
+                      <a:pPr>
+                        <a:defRPr sz="1300">
+                          <a:solidFill>
+                            <a:srgbClr val="333333"/>
+                          </a:solidFill>
+                          <a:latin typeface="Calibri"/>
+                        </a:defRPr>
+                      </a:pPr>
+                      <a:r>
+                        <a:t>Multiplicative penalty: 0–64% reduction. Not a linear weight.</a:t>
+                      </a:r>
+                    </a:p>
+                  </a:txBody>
+                  <a:tcPr>
+                    <a:solidFill>
+                      <a:srgbClr val="F0F4F8"/>
+                    </a:solidFill>
+                  </a:tcPr>
+                </a:tc>
+              </a:tr>
+            </a:tbl>
+          </a:graphicData>
+        </a:graphic>
+      </p:graphicFrame>
     </p:spTree>
   </p:cSld>
   <p:clrMapOvr>
@@ -3523,6 +4842,14 @@
 <file path=ppt/slides/slide5.xml><?xml version="1.0" encoding="utf-8"?>
 <p:sld xmlns:a="http://schemas.openxmlformats.org/drawingml/2006/main" xmlns:p="http://schemas.openxmlformats.org/presentationml/2006/main" xmlns:r="http://schemas.openxmlformats.org/officeDocument/2006/relationships">
   <p:cSld>
+    <p:bg>
+      <p:bgPr>
+        <a:solidFill>
+          <a:srgbClr val="FFFFFF"/>
+        </a:solidFill>
+        <a:effectLst/>
+      </p:bgPr>
+    </p:bg>
     <p:spTree>
       <p:nvGrpSpPr>
         <p:cNvPr id="1" name=""/>
@@ -3532,14 +4859,57 @@
       <p:grpSpPr/>
       <p:sp>
         <p:nvSpPr>
-          <p:cNvPr id="2" name="TextBox 1"/>
+          <p:cNvPr id="2" name="Rectangle 1"/>
+          <p:cNvSpPr/>
+          <p:nvPr/>
+        </p:nvSpPr>
+        <p:spPr>
+          <a:xfrm>
+            <a:off x="0" y="0"/>
+            <a:ext cx="12191695" cy="914400"/>
+          </a:xfrm>
+          <a:prstGeom prst="rect">
+            <a:avLst/>
+          </a:prstGeom>
+          <a:solidFill>
+            <a:srgbClr val="1A3C6E"/>
+          </a:solidFill>
+          <a:ln>
+            <a:noFill/>
+          </a:ln>
+        </p:spPr>
+        <p:style>
+          <a:lnRef idx="1">
+            <a:schemeClr val="accent1"/>
+          </a:lnRef>
+          <a:fillRef idx="3">
+            <a:schemeClr val="accent1"/>
+          </a:fillRef>
+          <a:effectRef idx="2">
+            <a:schemeClr val="accent1"/>
+          </a:effectRef>
+          <a:fontRef idx="minor">
+            <a:schemeClr val="lt1"/>
+          </a:fontRef>
+        </p:style>
+        <p:txBody>
+          <a:bodyPr rtlCol="0" anchor="ctr"/>
+          <a:lstStyle/>
+          <a:p>
+            <a:pPr algn="ctr"/>
+          </a:p>
+        </p:txBody>
+      </p:sp>
+      <p:sp>
+        <p:nvSpPr>
+          <p:cNvPr id="3" name="TextBox 2"/>
           <p:cNvSpPr txBox="1"/>
           <p:nvPr/>
         </p:nvSpPr>
         <p:spPr>
           <a:xfrm>
-            <a:off x="457200" y="274320"/>
-            <a:ext cx="10972800" cy="914400"/>
+            <a:off x="457200" y="182880"/>
+            <a:ext cx="10972800" cy="548640"/>
           </a:xfrm>
           <a:prstGeom prst="rect">
             <a:avLst/>
@@ -3547,77 +4917,2776 @@
           <a:noFill/>
         </p:spPr>
         <p:txBody>
-          <a:bodyPr wrap="none">
+          <a:bodyPr wrap="square">
             <a:spAutoFit/>
           </a:bodyPr>
           <a:lstStyle/>
           <a:p>
+            <a:pPr algn="l">
+              <a:defRPr sz="3200" b="1">
+                <a:solidFill>
+                  <a:srgbClr val="FFFFFF"/>
+                </a:solidFill>
+                <a:latin typeface="Calibri"/>
+              </a:defRPr>
+            </a:pPr>
+            <a:r>
+              <a:t>Honeypot Detection (12 Rules)</a:t>
+            </a:r>
+          </a:p>
+        </p:txBody>
+      </p:sp>
+      <p:sp>
+        <p:nvSpPr>
+          <p:cNvPr id="4" name="TextBox 3"/>
+          <p:cNvSpPr txBox="1"/>
+          <p:nvPr/>
+        </p:nvSpPr>
+        <p:spPr>
+          <a:xfrm>
+            <a:off x="640080" y="1188720"/>
+            <a:ext cx="10515600" cy="5029200"/>
+          </a:xfrm>
+          <a:prstGeom prst="rect">
+            <a:avLst/>
+          </a:prstGeom>
+          <a:noFill/>
+        </p:spPr>
+        <p:txBody>
+          <a:bodyPr wrap="square">
+            <a:spAutoFit/>
+          </a:bodyPr>
+          <a:lstStyle/>
+          <a:p>
             <a:pPr>
-              <a:defRPr sz="3200" b="1"/>
+              <a:spcAft>
+                <a:spcPts val="400"/>
+              </a:spcAft>
+              <a:defRPr sz="1500">
+                <a:solidFill>
+                  <a:srgbClr val="333333"/>
+                </a:solidFill>
+                <a:latin typeface="Calibri"/>
+              </a:defRPr>
             </a:pPr>
             <a:r>
+              <a:t>1. Keyword stuffing: non-tech title + 22+ skills → +0.30</a:t>
+            </a:r>
+          </a:p>
+          <a:p>
+            <a:pPr>
+              <a:spcAft>
+                <a:spcPts val="400"/>
+              </a:spcAft>
+              <a:defRPr sz="1500">
+                <a:solidFill>
+                  <a:srgbClr val="333333"/>
+                </a:solidFill>
+                <a:latin typeface="Calibri"/>
+              </a:defRPr>
+            </a:pPr>
+            <a:r>
+              <a:t>2. AI skill stuffing: non-tech title + 8+ AI keywords → +0.30</a:t>
+            </a:r>
+          </a:p>
+          <a:p>
+            <a:pPr>
+              <a:spcAft>
+                <a:spcPts val="400"/>
+              </a:spcAft>
+              <a:defRPr sz="1500">
+                <a:solidFill>
+                  <a:srgbClr val="333333"/>
+                </a:solidFill>
+                <a:latin typeface="Calibri"/>
+              </a:defRPr>
+            </a:pPr>
+            <a:r>
+              <a:t>3. Impossible breadth: 22+ skills total → +0.20</a:t>
+            </a:r>
+          </a:p>
+          <a:p>
+            <a:pPr>
+              <a:spcAft>
+                <a:spcPts val="400"/>
+              </a:spcAft>
+              <a:defRPr sz="1500">
+                <a:solidFill>
+                  <a:srgbClr val="333333"/>
+                </a:solidFill>
+                <a:latin typeface="Calibri"/>
+              </a:defRPr>
+            </a:pPr>
+            <a:r>
+              <a:t>4. Ghost profile: low response rate (&lt;10%) + high profile views (&gt;30) → +0.15</a:t>
+            </a:r>
+          </a:p>
+          <a:p>
+            <a:pPr>
+              <a:spcAft>
+                <a:spcPts val="400"/>
+              </a:spcAft>
+              <a:defRPr sz="1500">
+                <a:solidFill>
+                  <a:srgbClr val="333333"/>
+                </a:solidFill>
+                <a:latin typeface="Calibri"/>
+              </a:defRPr>
+            </a:pPr>
+            <a:r>
+              <a:t>5. Inactive: 200+ days inactive + not open to work → +0.15</a:t>
+            </a:r>
+          </a:p>
+          <a:p>
+            <a:pPr>
+              <a:spcAft>
+                <a:spcPts val="400"/>
+              </a:spcAft>
+              <a:defRPr sz="1500">
+                <a:solidFill>
+                  <a:srgbClr val="333333"/>
+                </a:solidFill>
+                <a:latin typeface="Calibri"/>
+              </a:defRPr>
+            </a:pPr>
+            <a:r>
+              <a:t>6. CV/speech focus without NLP/IR (JD disqualifier) → +0.20</a:t>
+            </a:r>
+          </a:p>
+          <a:p>
+            <a:pPr>
+              <a:spcAft>
+                <a:spcPts val="400"/>
+              </a:spcAft>
+              <a:defRPr sz="1500">
+                <a:solidFill>
+                  <a:srgbClr val="333333"/>
+                </a:solidFill>
+                <a:latin typeface="Calibri"/>
+              </a:defRPr>
+            </a:pPr>
+            <a:r>
+              <a:t>7. All-consulting background (JD explicitly avoids) → +0.25</a:t>
+            </a:r>
+          </a:p>
+          <a:p>
+            <a:pPr>
+              <a:spcAft>
+                <a:spcPts val="400"/>
+              </a:spcAft>
+              <a:defRPr sz="1500">
+                <a:solidFill>
+                  <a:srgbClr val="333333"/>
+                </a:solidFill>
+                <a:latin typeface="Calibri"/>
+              </a:defRPr>
+            </a:pPr>
+            <a:r>
+              <a:t>8. Pure research without product/startup experience → +0.20</a:t>
+            </a:r>
+          </a:p>
+          <a:p>
+            <a:pPr>
+              <a:spcAft>
+                <a:spcPts val="400"/>
+              </a:spcAft>
+              <a:defRPr sz="1500">
+                <a:solidFill>
+                  <a:srgbClr val="333333"/>
+                </a:solidFill>
+                <a:latin typeface="Calibri"/>
+              </a:defRPr>
+            </a:pPr>
+            <a:r>
+              <a:t>9. Fake/placeholder company name (synthetic profiles) → +0.50</a:t>
+            </a:r>
+          </a:p>
+          <a:p>
+            <a:pPr>
+              <a:spcAft>
+                <a:spcPts val="400"/>
+              </a:spcAft>
+              <a:defRPr sz="1500">
+                <a:solidFill>
+                  <a:srgbClr val="333333"/>
+                </a:solidFill>
+                <a:latin typeface="Calibri"/>
+              </a:defRPr>
+            </a:pPr>
+            <a:r>
+              <a:t>10. Non-tech keyword stuffing: 6+ AI/retrieval/ranking skills + 10+ total → +0.30</a:t>
+            </a:r>
+          </a:p>
+          <a:p>
+            <a:pPr>
+              <a:spcAft>
+                <a:spcPts val="400"/>
+              </a:spcAft>
+              <a:defRPr sz="1500">
+                <a:solidFill>
+                  <a:srgbClr val="333333"/>
+                </a:solidFill>
+                <a:latin typeface="Calibri"/>
+              </a:defRPr>
+            </a:pPr>
+            <a:r>
+              <a:t>11. Tech-non-ML title with zero/≤2 AI/retrieval/ranking skills → +0.50/+0.35</a:t>
+            </a:r>
+          </a:p>
+          <a:p>
+            <a:pPr>
+              <a:spcAft>
+                <a:spcPts val="400"/>
+              </a:spcAft>
+              <a:defRPr sz="1500">
+                <a:solidFill>
+                  <a:srgbClr val="333333"/>
+                </a:solidFill>
+                <a:latin typeface="Calibri"/>
+              </a:defRPr>
+            </a:pPr>
+            <a:r>
+              <a:t>12. All penalties stack to max 0.80; final: base × (1.0 − 0.8 × penalty)</a:t>
+            </a:r>
+          </a:p>
+        </p:txBody>
+      </p:sp>
+    </p:spTree>
+  </p:cSld>
+  <p:clrMapOvr>
+    <a:masterClrMapping/>
+  </p:clrMapOvr>
+</p:sld>
+</file>
+
+<file path=ppt/slides/slide6.xml><?xml version="1.0" encoding="utf-8"?>
+<p:sld xmlns:a="http://schemas.openxmlformats.org/drawingml/2006/main" xmlns:p="http://schemas.openxmlformats.org/presentationml/2006/main" xmlns:r="http://schemas.openxmlformats.org/officeDocument/2006/relationships">
+  <p:cSld>
+    <p:bg>
+      <p:bgPr>
+        <a:solidFill>
+          <a:srgbClr val="FFFFFF"/>
+        </a:solidFill>
+        <a:effectLst/>
+      </p:bgPr>
+    </p:bg>
+    <p:spTree>
+      <p:nvGrpSpPr>
+        <p:cNvPr id="1" name=""/>
+        <p:cNvGrpSpPr/>
+        <p:nvPr/>
+      </p:nvGrpSpPr>
+      <p:grpSpPr/>
+      <p:sp>
+        <p:nvSpPr>
+          <p:cNvPr id="2" name="Rectangle 1"/>
+          <p:cNvSpPr/>
+          <p:nvPr/>
+        </p:nvSpPr>
+        <p:spPr>
+          <a:xfrm>
+            <a:off x="0" y="0"/>
+            <a:ext cx="12191695" cy="914400"/>
+          </a:xfrm>
+          <a:prstGeom prst="rect">
+            <a:avLst/>
+          </a:prstGeom>
+          <a:solidFill>
+            <a:srgbClr val="1A3C6E"/>
+          </a:solidFill>
+          <a:ln>
+            <a:noFill/>
+          </a:ln>
+        </p:spPr>
+        <p:style>
+          <a:lnRef idx="1">
+            <a:schemeClr val="accent1"/>
+          </a:lnRef>
+          <a:fillRef idx="3">
+            <a:schemeClr val="accent1"/>
+          </a:fillRef>
+          <a:effectRef idx="2">
+            <a:schemeClr val="accent1"/>
+          </a:effectRef>
+          <a:fontRef idx="minor">
+            <a:schemeClr val="lt1"/>
+          </a:fontRef>
+        </p:style>
+        <p:txBody>
+          <a:bodyPr rtlCol="0" anchor="ctr"/>
+          <a:lstStyle/>
+          <a:p>
+            <a:pPr algn="ctr"/>
+          </a:p>
+        </p:txBody>
+      </p:sp>
+      <p:sp>
+        <p:nvSpPr>
+          <p:cNvPr id="3" name="TextBox 2"/>
+          <p:cNvSpPr txBox="1"/>
+          <p:nvPr/>
+        </p:nvSpPr>
+        <p:spPr>
+          <a:xfrm>
+            <a:off x="457200" y="182880"/>
+            <a:ext cx="10972800" cy="548640"/>
+          </a:xfrm>
+          <a:prstGeom prst="rect">
+            <a:avLst/>
+          </a:prstGeom>
+          <a:noFill/>
+        </p:spPr>
+        <p:txBody>
+          <a:bodyPr wrap="square">
+            <a:spAutoFit/>
+          </a:bodyPr>
+          <a:lstStyle/>
+          <a:p>
+            <a:pPr algn="l">
+              <a:defRPr sz="3200" b="1">
+                <a:solidFill>
+                  <a:srgbClr val="FFFFFF"/>
+                </a:solidFill>
+                <a:latin typeface="Calibri"/>
+              </a:defRPr>
+            </a:pPr>
+            <a:r>
+              <a:t>Key Fixes &amp; Design Decisions</a:t>
+            </a:r>
+          </a:p>
+        </p:txBody>
+      </p:sp>
+      <p:sp>
+        <p:nvSpPr>
+          <p:cNvPr id="4" name="TextBox 3"/>
+          <p:cNvSpPr txBox="1"/>
+          <p:nvPr/>
+        </p:nvSpPr>
+        <p:spPr>
+          <a:xfrm>
+            <a:off x="640080" y="1188720"/>
+            <a:ext cx="10515600" cy="5029200"/>
+          </a:xfrm>
+          <a:prstGeom prst="rect">
+            <a:avLst/>
+          </a:prstGeom>
+          <a:noFill/>
+        </p:spPr>
+        <p:txBody>
+          <a:bodyPr wrap="square">
+            <a:spAutoFit/>
+          </a:bodyPr>
+          <a:lstStyle/>
+          <a:p>
+            <a:pPr>
+              <a:spcAft>
+                <a:spcPts val="400"/>
+              </a:spcAft>
+              <a:defRPr sz="1400">
+                <a:solidFill>
+                  <a:srgbClr val="333333"/>
+                </a:solidFill>
+                <a:latin typeface="Calibri"/>
+              </a:defRPr>
+            </a:pPr>
+            <a:r>
+              <a:t>Removed "ai" from JD_SKILLS_AI (2-char keyword caused 35,544 false-positive matches: airflow, tailwind, langchain, faiss, llamaindex all falsely counted as AI)</a:t>
+            </a:r>
+          </a:p>
+          <a:p>
+            <a:pPr>
+              <a:spcAft>
+                <a:spcPts val="400"/>
+              </a:spcAft>
+              <a:defRPr sz="1400">
+                <a:solidFill>
+                  <a:srgbClr val="333333"/>
+                </a:solidFill>
+                <a:latin typeface="Calibri"/>
+              </a:defRPr>
+            </a:pPr>
+            <a:r>
+              <a:t>Enriched profile_text for FAISS embedding with career_history descriptions (last 3 jobs, 200 chars each) and education — JD query matching now sees actual work experience</a:t>
+            </a:r>
+          </a:p>
+          <a:p>
+            <a:pPr>
+              <a:spcAft>
+                <a:spcPts val="400"/>
+              </a:spcAft>
+              <a:defRPr sz="1400">
+                <a:solidFill>
+                  <a:srgbClr val="333333"/>
+                </a:solidFill>
+                <a:latin typeface="Calibri"/>
+              </a:defRPr>
+            </a:pPr>
+            <a:r>
+              <a:t>Fixed empty-title substring bug ('' in key is True for every Python string, matches first TITLE_SCORES key with score 0.90)</a:t>
+            </a:r>
+          </a:p>
+          <a:p>
+            <a:pPr>
+              <a:spcAft>
+                <a:spcPts val="400"/>
+              </a:spcAft>
+              <a:defRPr sz="1400">
+                <a:solidFill>
+                  <a:srgbClr val="333333"/>
+                </a:solidFill>
+                <a:latin typeface="Calibri"/>
+              </a:defRPr>
+            </a:pPr>
+            <a:r>
+              <a:t>Removed redundant additive honeypot penalty and consulting double-penalty (company_score + extra multiplier) — each signal contributes exactly once</a:t>
+            </a:r>
+          </a:p>
+          <a:p>
+            <a:pPr>
+              <a:spcAft>
+                <a:spcPts val="400"/>
+              </a:spcAft>
+              <a:defRPr sz="1400">
+                <a:solidFill>
+                  <a:srgbClr val="333333"/>
+                </a:solidFill>
+                <a:latin typeface="Calibri"/>
+              </a:defRPr>
+            </a:pPr>
+            <a:r>
+              <a:t>Fake company detection: 59,749 candidates with placeholder company names (Wayne Enterprises, Initech, etc.) now penalized with +0.50</a:t>
+            </a:r>
+          </a:p>
+          <a:p>
+            <a:pPr>
+              <a:spcAft>
+                <a:spcPts val="400"/>
+              </a:spcAft>
+              <a:defRPr sz="1400">
+                <a:solidFill>
+                  <a:srgbClr val="333333"/>
+                </a:solidFill>
+                <a:latin typeface="Calibri"/>
+              </a:defRPr>
+            </a:pPr>
+            <a:r>
+              <a:t>Skill relevance factor: less aggressive (0.50/0.65/0.80 instead of 0.25/0.40/0.70) to avoid double-penalizing via both skill_score and semantic_effective</a:t>
+            </a:r>
+          </a:p>
+          <a:p>
+            <a:pPr>
+              <a:spcAft>
+                <a:spcPts val="400"/>
+              </a:spcAft>
+              <a:defRPr sz="1400">
+                <a:solidFill>
+                  <a:srgbClr val="333333"/>
+                </a:solidFill>
+                <a:latin typeface="Calibri"/>
+              </a:defRPr>
+            </a:pPr>
+            <a:r>
+              <a:t>Widened notice period modifier: ≤30d → +5%, &gt;90d → -15% (was 2%/7%) — JD specifically values quick joiners</a:t>
+            </a:r>
+          </a:p>
+          <a:p>
+            <a:pPr>
+              <a:spcAft>
+                <a:spcPts val="400"/>
+              </a:spcAft>
+              <a:defRPr sz="1400">
+                <a:solidFill>
+                  <a:srgbClr val="333333"/>
+                </a:solidFill>
+                <a:latin typeface="Calibri"/>
+              </a:defRPr>
+            </a:pPr>
+            <a:r>
+              <a:t>Removed 3 double-counting bugs: days_since_active, open_to_work, and PUNE_NOIDA location each contributed twice to the final score</a:t>
+            </a:r>
+          </a:p>
+          <a:p>
+            <a:pPr>
+              <a:spcAft>
+                <a:spcPts val="400"/>
+              </a:spcAft>
+              <a:defRPr sz="1400">
+                <a:solidFill>
+                  <a:srgbClr val="333333"/>
+                </a:solidFill>
+                <a:latin typeface="Calibri"/>
+              </a:defRPr>
+            </a:pPr>
+            <a:r>
+              <a:t>FAISS min-max normalized over top-1000 (not top-10000) for better discriminability among candidates that could make top-100</a:t>
+            </a:r>
+          </a:p>
+        </p:txBody>
+      </p:sp>
+    </p:spTree>
+  </p:cSld>
+  <p:clrMapOvr>
+    <a:masterClrMapping/>
+  </p:clrMapOvr>
+</p:sld>
+</file>
+
+<file path=ppt/slides/slide7.xml><?xml version="1.0" encoding="utf-8"?>
+<p:sld xmlns:a="http://schemas.openxmlformats.org/drawingml/2006/main" xmlns:p="http://schemas.openxmlformats.org/presentationml/2006/main" xmlns:r="http://schemas.openxmlformats.org/officeDocument/2006/relationships">
+  <p:cSld>
+    <p:bg>
+      <p:bgPr>
+        <a:solidFill>
+          <a:srgbClr val="FFFFFF"/>
+        </a:solidFill>
+        <a:effectLst/>
+      </p:bgPr>
+    </p:bg>
+    <p:spTree>
+      <p:nvGrpSpPr>
+        <p:cNvPr id="1" name=""/>
+        <p:cNvGrpSpPr/>
+        <p:nvPr/>
+      </p:nvGrpSpPr>
+      <p:grpSpPr/>
+      <p:sp>
+        <p:nvSpPr>
+          <p:cNvPr id="2" name="Rectangle 1"/>
+          <p:cNvSpPr/>
+          <p:nvPr/>
+        </p:nvSpPr>
+        <p:spPr>
+          <a:xfrm>
+            <a:off x="0" y="0"/>
+            <a:ext cx="12191695" cy="914400"/>
+          </a:xfrm>
+          <a:prstGeom prst="rect">
+            <a:avLst/>
+          </a:prstGeom>
+          <a:solidFill>
+            <a:srgbClr val="1A3C6E"/>
+          </a:solidFill>
+          <a:ln>
+            <a:noFill/>
+          </a:ln>
+        </p:spPr>
+        <p:style>
+          <a:lnRef idx="1">
+            <a:schemeClr val="accent1"/>
+          </a:lnRef>
+          <a:fillRef idx="3">
+            <a:schemeClr val="accent1"/>
+          </a:fillRef>
+          <a:effectRef idx="2">
+            <a:schemeClr val="accent1"/>
+          </a:effectRef>
+          <a:fontRef idx="minor">
+            <a:schemeClr val="lt1"/>
+          </a:fontRef>
+        </p:style>
+        <p:txBody>
+          <a:bodyPr rtlCol="0" anchor="ctr"/>
+          <a:lstStyle/>
+          <a:p>
+            <a:pPr algn="ctr"/>
+          </a:p>
+        </p:txBody>
+      </p:sp>
+      <p:sp>
+        <p:nvSpPr>
+          <p:cNvPr id="3" name="TextBox 2"/>
+          <p:cNvSpPr txBox="1"/>
+          <p:nvPr/>
+        </p:nvSpPr>
+        <p:spPr>
+          <a:xfrm>
+            <a:off x="457200" y="182880"/>
+            <a:ext cx="10972800" cy="548640"/>
+          </a:xfrm>
+          <a:prstGeom prst="rect">
+            <a:avLst/>
+          </a:prstGeom>
+          <a:noFill/>
+        </p:spPr>
+        <p:txBody>
+          <a:bodyPr wrap="square">
+            <a:spAutoFit/>
+          </a:bodyPr>
+          <a:lstStyle/>
+          <a:p>
+            <a:pPr algn="l">
+              <a:defRPr sz="3200" b="1">
+                <a:solidFill>
+                  <a:srgbClr val="FFFFFF"/>
+                </a:solidFill>
+                <a:latin typeface="Calibri"/>
+              </a:defRPr>
+            </a:pPr>
+            <a:r>
               <a:t>Results</a:t>
             </a:r>
           </a:p>
+        </p:txBody>
+      </p:sp>
+      <p:sp>
+        <p:nvSpPr>
+          <p:cNvPr id="4" name="TextBox 3"/>
+          <p:cNvSpPr txBox="1"/>
+          <p:nvPr/>
+        </p:nvSpPr>
+        <p:spPr>
+          <a:xfrm>
+            <a:off x="640080" y="1188720"/>
+            <a:ext cx="10515600" cy="2286000"/>
+          </a:xfrm>
+          <a:prstGeom prst="rect">
+            <a:avLst/>
+          </a:prstGeom>
+          <a:noFill/>
+        </p:spPr>
+        <p:txBody>
+          <a:bodyPr wrap="square">
+            <a:spAutoFit/>
+          </a:bodyPr>
+          <a:lstStyle/>
           <a:p>
             <a:pPr>
-              <a:defRPr sz="1800"/>
+              <a:spcAft>
+                <a:spcPts val="600"/>
+              </a:spcAft>
+              <a:defRPr sz="1700">
+                <a:solidFill>
+                  <a:srgbClr val="333333"/>
+                </a:solidFill>
+                <a:latin typeface="Calibri"/>
+              </a:defRPr>
             </a:pPr>
             <a:r>
-              <a:t>Score range: 0.9205 - 0.8245 (top-100)</a:t>
+              <a:t>Score range: 0.5895 – 0.9704 (top-100)</a:t>
             </a:r>
           </a:p>
           <a:p>
             <a:pPr>
-              <a:defRPr sz="1800"/>
+              <a:spcAft>
+                <a:spcPts val="600"/>
+              </a:spcAft>
+              <a:defRPr sz="1700">
+                <a:solidFill>
+                  <a:srgbClr val="333333"/>
+                </a:solidFill>
+                <a:latin typeface="Calibri"/>
+              </a:defRPr>
             </a:pPr>
             <a:r>
-              <a:t>Phase B runtime: 12.5s / 300s budget</a:t>
+              <a:t>Unique scores: 98/100 (2 tied pairs, resolved by candidate_id ascending)</a:t>
             </a:r>
           </a:p>
           <a:p>
             <a:pPr>
-              <a:defRPr sz="1800"/>
+              <a:spcAft>
+                <a:spcPts val="600"/>
+              </a:spcAft>
+              <a:defRPr sz="1700">
+                <a:solidFill>
+                  <a:srgbClr val="333333"/>
+                </a:solidFill>
+                <a:latin typeface="Calibri"/>
+              </a:defRPr>
             </a:pPr>
             <a:r>
+              <a:t>Honeypots in top-100: 0/100 (0% — well under 10% disqualification threshold)</a:t>
+            </a:r>
+          </a:p>
+          <a:p>
+            <a:pPr>
+              <a:spcAft>
+                <a:spcPts val="600"/>
+              </a:spcAft>
+              <a:defRPr sz="1700">
+                <a:solidFill>
+                  <a:srgbClr val="333333"/>
+                </a:solidFill>
+                <a:latin typeface="Calibri"/>
+              </a:defRPr>
+            </a:pPr>
+            <a:r>
+              <a:t>Fake companies in top-100: 0/100</a:t>
+            </a:r>
+          </a:p>
+          <a:p>
+            <a:pPr>
+              <a:spcAft>
+                <a:spcPts val="600"/>
+              </a:spcAft>
+              <a:defRPr sz="1700">
+                <a:solidFill>
+                  <a:srgbClr val="333333"/>
+                </a:solidFill>
+                <a:latin typeface="Calibri"/>
+              </a:defRPr>
+            </a:pPr>
+            <a:r>
+              <a:t>All-consulting in top-100: 0/100</a:t>
+            </a:r>
+          </a:p>
+          <a:p>
+            <a:pPr>
+              <a:spcAft>
+                <a:spcPts val="600"/>
+              </a:spcAft>
+              <a:defRPr sz="1700">
+                <a:solidFill>
+                  <a:srgbClr val="333333"/>
+                </a:solidFill>
+                <a:latin typeface="Calibri"/>
+              </a:defRPr>
+            </a:pPr>
+            <a:r>
+              <a:t>Phase B runtime: 14.2s / 300s budget (4.7% of limit)</a:t>
+            </a:r>
+          </a:p>
+          <a:p>
+            <a:pPr>
+              <a:spcAft>
+                <a:spcPts val="600"/>
+              </a:spcAft>
+              <a:defRPr sz="1700">
+                <a:solidFill>
+                  <a:srgbClr val="333333"/>
+                </a:solidFill>
+                <a:latin typeface="Calibri"/>
+              </a:defRPr>
+            </a:pPr>
+            <a:r>
               <a:t>Validation: PASS (official validate_submission.py)</a:t>
             </a:r>
           </a:p>
+        </p:txBody>
+      </p:sp>
+      <p:sp>
+        <p:nvSpPr>
+          <p:cNvPr id="5" name="TextBox 4"/>
+          <p:cNvSpPr txBox="1"/>
+          <p:nvPr/>
+        </p:nvSpPr>
+        <p:spPr>
+          <a:xfrm>
+            <a:off x="640080" y="3657600"/>
+            <a:ext cx="10515600" cy="365760"/>
+          </a:xfrm>
+          <a:prstGeom prst="rect">
+            <a:avLst/>
+          </a:prstGeom>
+          <a:noFill/>
+        </p:spPr>
+        <p:txBody>
+          <a:bodyPr wrap="square">
+            <a:spAutoFit/>
+          </a:bodyPr>
+          <a:lstStyle/>
+          <a:p>
+            <a:pPr algn="l">
+              <a:defRPr sz="2000" b="1">
+                <a:solidFill>
+                  <a:srgbClr val="2D6BC4"/>
+                </a:solidFill>
+                <a:latin typeface="Calibri"/>
+              </a:defRPr>
+            </a:pPr>
+            <a:r>
+              <a:t>Top 10 Candidates</a:t>
+            </a:r>
+          </a:p>
+        </p:txBody>
+      </p:sp>
+      <p:graphicFrame>
+        <p:nvGraphicFramePr>
+          <p:cNvPr id="6" name="Table 5"/>
+          <p:cNvGraphicFramePr>
+            <a:graphicFrameLocks noGrp="1"/>
+          </p:cNvGraphicFramePr>
+          <p:nvPr/>
+        </p:nvGraphicFramePr>
+        <p:xfrm>
+          <a:off x="640080" y="4114800"/>
+          <a:ext cx="10515600" cy="2560320"/>
+        </p:xfrm>
+        <a:graphic>
+          <a:graphicData uri="http://schemas.openxmlformats.org/drawingml/2006/table">
+            <a:tbl>
+              <a:tblPr firstRow="1" bandRow="1">
+                <a:tableStyleId>{5C22544A-7EE6-4342-B048-85BDC9FD1C3A}</a:tableStyleId>
+              </a:tblPr>
+              <a:tblGrid>
+                <a:gridCol w="731520"/>
+                <a:gridCol w="1645920"/>
+                <a:gridCol w="1828800"/>
+                <a:gridCol w="1371600"/>
+                <a:gridCol w="4937760"/>
+              </a:tblGrid>
+              <a:tr h="232756">
+                <a:tc>
+                  <a:txBody>
+                    <a:bodyPr/>
+                    <a:lstStyle/>
+                    <a:p>
+                      <a:pPr algn="ctr">
+                        <a:defRPr sz="1200" b="1">
+                          <a:solidFill>
+                            <a:srgbClr val="FFFFFF"/>
+                          </a:solidFill>
+                          <a:latin typeface="Calibri"/>
+                        </a:defRPr>
+                      </a:pPr>
+                      <a:r>
+                        <a:t>Rank</a:t>
+                      </a:r>
+                    </a:p>
+                  </a:txBody>
+                  <a:tcPr>
+                    <a:solidFill>
+                      <a:srgbClr val="1A3C6E"/>
+                    </a:solidFill>
+                  </a:tcPr>
+                </a:tc>
+                <a:tc>
+                  <a:txBody>
+                    <a:bodyPr/>
+                    <a:lstStyle/>
+                    <a:p>
+                      <a:pPr algn="ctr">
+                        <a:defRPr sz="1200" b="1">
+                          <a:solidFill>
+                            <a:srgbClr val="FFFFFF"/>
+                          </a:solidFill>
+                          <a:latin typeface="Calibri"/>
+                        </a:defRPr>
+                      </a:pPr>
+                      <a:r>
+                        <a:t>Candidate</a:t>
+                      </a:r>
+                    </a:p>
+                  </a:txBody>
+                  <a:tcPr>
+                    <a:solidFill>
+                      <a:srgbClr val="1A3C6E"/>
+                    </a:solidFill>
+                  </a:tcPr>
+                </a:tc>
+                <a:tc>
+                  <a:txBody>
+                    <a:bodyPr/>
+                    <a:lstStyle/>
+                    <a:p>
+                      <a:pPr algn="ctr">
+                        <a:defRPr sz="1200" b="1">
+                          <a:solidFill>
+                            <a:srgbClr val="FFFFFF"/>
+                          </a:solidFill>
+                          <a:latin typeface="Calibri"/>
+                        </a:defRPr>
+                      </a:pPr>
+                      <a:r>
+                        <a:t>Company</a:t>
+                      </a:r>
+                    </a:p>
+                  </a:txBody>
+                  <a:tcPr>
+                    <a:solidFill>
+                      <a:srgbClr val="1A3C6E"/>
+                    </a:solidFill>
+                  </a:tcPr>
+                </a:tc>
+                <a:tc>
+                  <a:txBody>
+                    <a:bodyPr/>
+                    <a:lstStyle/>
+                    <a:p>
+                      <a:pPr algn="ctr">
+                        <a:defRPr sz="1200" b="1">
+                          <a:solidFill>
+                            <a:srgbClr val="FFFFFF"/>
+                          </a:solidFill>
+                          <a:latin typeface="Calibri"/>
+                        </a:defRPr>
+                      </a:pPr>
+                      <a:r>
+                        <a:t>Score</a:t>
+                      </a:r>
+                    </a:p>
+                  </a:txBody>
+                  <a:tcPr>
+                    <a:solidFill>
+                      <a:srgbClr val="1A3C6E"/>
+                    </a:solidFill>
+                  </a:tcPr>
+                </a:tc>
+                <a:tc>
+                  <a:txBody>
+                    <a:bodyPr/>
+                    <a:lstStyle/>
+                    <a:p>
+                      <a:pPr algn="ctr">
+                        <a:defRPr sz="1200" b="1">
+                          <a:solidFill>
+                            <a:srgbClr val="FFFFFF"/>
+                          </a:solidFill>
+                          <a:latin typeface="Calibri"/>
+                        </a:defRPr>
+                      </a:pPr>
+                      <a:r>
+                        <a:t>Title</a:t>
+                      </a:r>
+                    </a:p>
+                  </a:txBody>
+                  <a:tcPr>
+                    <a:solidFill>
+                      <a:srgbClr val="1A3C6E"/>
+                    </a:solidFill>
+                  </a:tcPr>
+                </a:tc>
+              </a:tr>
+              <a:tr h="232756">
+                <a:tc>
+                  <a:txBody>
+                    <a:bodyPr/>
+                    <a:lstStyle/>
+                    <a:p>
+                      <a:pPr algn="ctr">
+                        <a:defRPr sz="1200" b="0">
+                          <a:solidFill>
+                            <a:srgbClr val="333333"/>
+                          </a:solidFill>
+                          <a:latin typeface="Calibri"/>
+                        </a:defRPr>
+                      </a:pPr>
+                      <a:r>
+                        <a:t>1</a:t>
+                      </a:r>
+                    </a:p>
+                  </a:txBody>
+                  <a:tcPr>
+                    <a:solidFill>
+                      <a:srgbClr val="FFFFFF"/>
+                    </a:solidFill>
+                  </a:tcPr>
+                </a:tc>
+                <a:tc>
+                  <a:txBody>
+                    <a:bodyPr/>
+                    <a:lstStyle/>
+                    <a:p>
+                      <a:pPr algn="ctr">
+                        <a:defRPr sz="1200" b="0">
+                          <a:solidFill>
+                            <a:srgbClr val="333333"/>
+                          </a:solidFill>
+                          <a:latin typeface="Calibri"/>
+                        </a:defRPr>
+                      </a:pPr>
+                      <a:r>
+                        <a:t>CAND_0002025</a:t>
+                      </a:r>
+                    </a:p>
+                  </a:txBody>
+                  <a:tcPr>
+                    <a:solidFill>
+                      <a:srgbClr val="FFFFFF"/>
+                    </a:solidFill>
+                  </a:tcPr>
+                </a:tc>
+                <a:tc>
+                  <a:txBody>
+                    <a:bodyPr/>
+                    <a:lstStyle/>
+                    <a:p>
+                      <a:pPr algn="ctr">
+                        <a:defRPr sz="1200" b="0">
+                          <a:solidFill>
+                            <a:srgbClr val="333333"/>
+                          </a:solidFill>
+                          <a:latin typeface="Calibri"/>
+                        </a:defRPr>
+                      </a:pPr>
+                      <a:r>
+                        <a:t>Apple</a:t>
+                      </a:r>
+                    </a:p>
+                  </a:txBody>
+                  <a:tcPr>
+                    <a:solidFill>
+                      <a:srgbClr val="FFFFFF"/>
+                    </a:solidFill>
+                  </a:tcPr>
+                </a:tc>
+                <a:tc>
+                  <a:txBody>
+                    <a:bodyPr/>
+                    <a:lstStyle/>
+                    <a:p>
+                      <a:pPr algn="ctr">
+                        <a:defRPr sz="1200" b="0">
+                          <a:solidFill>
+                            <a:srgbClr val="333333"/>
+                          </a:solidFill>
+                          <a:latin typeface="Calibri"/>
+                        </a:defRPr>
+                      </a:pPr>
+                      <a:r>
+                        <a:t>0.9704</a:t>
+                      </a:r>
+                    </a:p>
+                  </a:txBody>
+                  <a:tcPr>
+                    <a:solidFill>
+                      <a:srgbClr val="FFFFFF"/>
+                    </a:solidFill>
+                  </a:tcPr>
+                </a:tc>
+                <a:tc>
+                  <a:txBody>
+                    <a:bodyPr/>
+                    <a:lstStyle/>
+                    <a:p>
+                      <a:pPr algn="ctr">
+                        <a:defRPr sz="1200" b="0">
+                          <a:solidFill>
+                            <a:srgbClr val="333333"/>
+                          </a:solidFill>
+                          <a:latin typeface="Calibri"/>
+                        </a:defRPr>
+                      </a:pPr>
+                      <a:r>
+                        <a:t>Senior AI Engineer</a:t>
+                      </a:r>
+                    </a:p>
+                  </a:txBody>
+                  <a:tcPr>
+                    <a:solidFill>
+                      <a:srgbClr val="FFFFFF"/>
+                    </a:solidFill>
+                  </a:tcPr>
+                </a:tc>
+              </a:tr>
+              <a:tr h="232756">
+                <a:tc>
+                  <a:txBody>
+                    <a:bodyPr/>
+                    <a:lstStyle/>
+                    <a:p>
+                      <a:pPr algn="ctr">
+                        <a:defRPr sz="1200" b="0">
+                          <a:solidFill>
+                            <a:srgbClr val="333333"/>
+                          </a:solidFill>
+                          <a:latin typeface="Calibri"/>
+                        </a:defRPr>
+                      </a:pPr>
+                      <a:r>
+                        <a:t>2</a:t>
+                      </a:r>
+                    </a:p>
+                  </a:txBody>
+                  <a:tcPr>
+                    <a:solidFill>
+                      <a:srgbClr val="F0F4F8"/>
+                    </a:solidFill>
+                  </a:tcPr>
+                </a:tc>
+                <a:tc>
+                  <a:txBody>
+                    <a:bodyPr/>
+                    <a:lstStyle/>
+                    <a:p>
+                      <a:pPr algn="ctr">
+                        <a:defRPr sz="1200" b="0">
+                          <a:solidFill>
+                            <a:srgbClr val="333333"/>
+                          </a:solidFill>
+                          <a:latin typeface="Calibri"/>
+                        </a:defRPr>
+                      </a:pPr>
+                      <a:r>
+                        <a:t>CAND_0079387</a:t>
+                      </a:r>
+                    </a:p>
+                  </a:txBody>
+                  <a:tcPr>
+                    <a:solidFill>
+                      <a:srgbClr val="F0F4F8"/>
+                    </a:solidFill>
+                  </a:tcPr>
+                </a:tc>
+                <a:tc>
+                  <a:txBody>
+                    <a:bodyPr/>
+                    <a:lstStyle/>
+                    <a:p>
+                      <a:pPr algn="ctr">
+                        <a:defRPr sz="1200" b="0">
+                          <a:solidFill>
+                            <a:srgbClr val="333333"/>
+                          </a:solidFill>
+                          <a:latin typeface="Calibri"/>
+                        </a:defRPr>
+                      </a:pPr>
+                      <a:r>
+                        <a:t>Microsoft</a:t>
+                      </a:r>
+                    </a:p>
+                  </a:txBody>
+                  <a:tcPr>
+                    <a:solidFill>
+                      <a:srgbClr val="F0F4F8"/>
+                    </a:solidFill>
+                  </a:tcPr>
+                </a:tc>
+                <a:tc>
+                  <a:txBody>
+                    <a:bodyPr/>
+                    <a:lstStyle/>
+                    <a:p>
+                      <a:pPr algn="ctr">
+                        <a:defRPr sz="1200" b="0">
+                          <a:solidFill>
+                            <a:srgbClr val="333333"/>
+                          </a:solidFill>
+                          <a:latin typeface="Calibri"/>
+                        </a:defRPr>
+                      </a:pPr>
+                      <a:r>
+                        <a:t>0.9378</a:t>
+                      </a:r>
+                    </a:p>
+                  </a:txBody>
+                  <a:tcPr>
+                    <a:solidFill>
+                      <a:srgbClr val="F0F4F8"/>
+                    </a:solidFill>
+                  </a:tcPr>
+                </a:tc>
+                <a:tc>
+                  <a:txBody>
+                    <a:bodyPr/>
+                    <a:lstStyle/>
+                    <a:p>
+                      <a:pPr algn="ctr">
+                        <a:defRPr sz="1200" b="0">
+                          <a:solidFill>
+                            <a:srgbClr val="333333"/>
+                          </a:solidFill>
+                          <a:latin typeface="Calibri"/>
+                        </a:defRPr>
+                      </a:pPr>
+                      <a:r>
+                        <a:t>AI Engineer</a:t>
+                      </a:r>
+                    </a:p>
+                  </a:txBody>
+                  <a:tcPr>
+                    <a:solidFill>
+                      <a:srgbClr val="F0F4F8"/>
+                    </a:solidFill>
+                  </a:tcPr>
+                </a:tc>
+              </a:tr>
+              <a:tr h="232756">
+                <a:tc>
+                  <a:txBody>
+                    <a:bodyPr/>
+                    <a:lstStyle/>
+                    <a:p>
+                      <a:pPr algn="ctr">
+                        <a:defRPr sz="1200" b="0">
+                          <a:solidFill>
+                            <a:srgbClr val="333333"/>
+                          </a:solidFill>
+                          <a:latin typeface="Calibri"/>
+                        </a:defRPr>
+                      </a:pPr>
+                      <a:r>
+                        <a:t>3</a:t>
+                      </a:r>
+                    </a:p>
+                  </a:txBody>
+                  <a:tcPr>
+                    <a:solidFill>
+                      <a:srgbClr val="FFFFFF"/>
+                    </a:solidFill>
+                  </a:tcPr>
+                </a:tc>
+                <a:tc>
+                  <a:txBody>
+                    <a:bodyPr/>
+                    <a:lstStyle/>
+                    <a:p>
+                      <a:pPr algn="ctr">
+                        <a:defRPr sz="1200" b="0">
+                          <a:solidFill>
+                            <a:srgbClr val="333333"/>
+                          </a:solidFill>
+                          <a:latin typeface="Calibri"/>
+                        </a:defRPr>
+                      </a:pPr>
+                      <a:r>
+                        <a:t>CAND_0087630</a:t>
+                      </a:r>
+                    </a:p>
+                  </a:txBody>
+                  <a:tcPr>
+                    <a:solidFill>
+                      <a:srgbClr val="FFFFFF"/>
+                    </a:solidFill>
+                  </a:tcPr>
+                </a:tc>
+                <a:tc>
+                  <a:txBody>
+                    <a:bodyPr/>
+                    <a:lstStyle/>
+                    <a:p>
+                      <a:pPr algn="ctr">
+                        <a:defRPr sz="1200" b="0">
+                          <a:solidFill>
+                            <a:srgbClr val="333333"/>
+                          </a:solidFill>
+                          <a:latin typeface="Calibri"/>
+                        </a:defRPr>
+                      </a:pPr>
+                      <a:r>
+                        <a:t>Vedantu</a:t>
+                      </a:r>
+                    </a:p>
+                  </a:txBody>
+                  <a:tcPr>
+                    <a:solidFill>
+                      <a:srgbClr val="FFFFFF"/>
+                    </a:solidFill>
+                  </a:tcPr>
+                </a:tc>
+                <a:tc>
+                  <a:txBody>
+                    <a:bodyPr/>
+                    <a:lstStyle/>
+                    <a:p>
+                      <a:pPr algn="ctr">
+                        <a:defRPr sz="1200" b="0">
+                          <a:solidFill>
+                            <a:srgbClr val="333333"/>
+                          </a:solidFill>
+                          <a:latin typeface="Calibri"/>
+                        </a:defRPr>
+                      </a:pPr>
+                      <a:r>
+                        <a:t>0.8483</a:t>
+                      </a:r>
+                    </a:p>
+                  </a:txBody>
+                  <a:tcPr>
+                    <a:solidFill>
+                      <a:srgbClr val="FFFFFF"/>
+                    </a:solidFill>
+                  </a:tcPr>
+                </a:tc>
+                <a:tc>
+                  <a:txBody>
+                    <a:bodyPr/>
+                    <a:lstStyle/>
+                    <a:p>
+                      <a:pPr algn="ctr">
+                        <a:defRPr sz="1200" b="0">
+                          <a:solidFill>
+                            <a:srgbClr val="333333"/>
+                          </a:solidFill>
+                          <a:latin typeface="Calibri"/>
+                        </a:defRPr>
+                      </a:pPr>
+                      <a:r>
+                        <a:t>AI Engineer</a:t>
+                      </a:r>
+                    </a:p>
+                  </a:txBody>
+                  <a:tcPr>
+                    <a:solidFill>
+                      <a:srgbClr val="FFFFFF"/>
+                    </a:solidFill>
+                  </a:tcPr>
+                </a:tc>
+              </a:tr>
+              <a:tr h="232756">
+                <a:tc>
+                  <a:txBody>
+                    <a:bodyPr/>
+                    <a:lstStyle/>
+                    <a:p>
+                      <a:pPr algn="ctr">
+                        <a:defRPr sz="1200" b="0">
+                          <a:solidFill>
+                            <a:srgbClr val="333333"/>
+                          </a:solidFill>
+                          <a:latin typeface="Calibri"/>
+                        </a:defRPr>
+                      </a:pPr>
+                      <a:r>
+                        <a:t>4</a:t>
+                      </a:r>
+                    </a:p>
+                  </a:txBody>
+                  <a:tcPr>
+                    <a:solidFill>
+                      <a:srgbClr val="F0F4F8"/>
+                    </a:solidFill>
+                  </a:tcPr>
+                </a:tc>
+                <a:tc>
+                  <a:txBody>
+                    <a:bodyPr/>
+                    <a:lstStyle/>
+                    <a:p>
+                      <a:pPr algn="ctr">
+                        <a:defRPr sz="1200" b="0">
+                          <a:solidFill>
+                            <a:srgbClr val="333333"/>
+                          </a:solidFill>
+                          <a:latin typeface="Calibri"/>
+                        </a:defRPr>
+                      </a:pPr>
+                      <a:r>
+                        <a:t>CAND_0045250</a:t>
+                      </a:r>
+                    </a:p>
+                  </a:txBody>
+                  <a:tcPr>
+                    <a:solidFill>
+                      <a:srgbClr val="F0F4F8"/>
+                    </a:solidFill>
+                  </a:tcPr>
+                </a:tc>
+                <a:tc>
+                  <a:txBody>
+                    <a:bodyPr/>
+                    <a:lstStyle/>
+                    <a:p>
+                      <a:pPr algn="ctr">
+                        <a:defRPr sz="1200" b="0">
+                          <a:solidFill>
+                            <a:srgbClr val="333333"/>
+                          </a:solidFill>
+                          <a:latin typeface="Calibri"/>
+                        </a:defRPr>
+                      </a:pPr>
+                      <a:r>
+                        <a:t>Rephrase.ai</a:t>
+                      </a:r>
+                    </a:p>
+                  </a:txBody>
+                  <a:tcPr>
+                    <a:solidFill>
+                      <a:srgbClr val="F0F4F8"/>
+                    </a:solidFill>
+                  </a:tcPr>
+                </a:tc>
+                <a:tc>
+                  <a:txBody>
+                    <a:bodyPr/>
+                    <a:lstStyle/>
+                    <a:p>
+                      <a:pPr algn="ctr">
+                        <a:defRPr sz="1200" b="0">
+                          <a:solidFill>
+                            <a:srgbClr val="333333"/>
+                          </a:solidFill>
+                          <a:latin typeface="Calibri"/>
+                        </a:defRPr>
+                      </a:pPr>
+                      <a:r>
+                        <a:t>0.8439</a:t>
+                      </a:r>
+                    </a:p>
+                  </a:txBody>
+                  <a:tcPr>
+                    <a:solidFill>
+                      <a:srgbClr val="F0F4F8"/>
+                    </a:solidFill>
+                  </a:tcPr>
+                </a:tc>
+                <a:tc>
+                  <a:txBody>
+                    <a:bodyPr/>
+                    <a:lstStyle/>
+                    <a:p>
+                      <a:pPr algn="ctr">
+                        <a:defRPr sz="1200" b="0">
+                          <a:solidFill>
+                            <a:srgbClr val="333333"/>
+                          </a:solidFill>
+                          <a:latin typeface="Calibri"/>
+                        </a:defRPr>
+                      </a:pPr>
+                      <a:r>
+                        <a:t>Applied ML Engineer</a:t>
+                      </a:r>
+                    </a:p>
+                  </a:txBody>
+                  <a:tcPr>
+                    <a:solidFill>
+                      <a:srgbClr val="F0F4F8"/>
+                    </a:solidFill>
+                  </a:tcPr>
+                </a:tc>
+              </a:tr>
+              <a:tr h="232756">
+                <a:tc>
+                  <a:txBody>
+                    <a:bodyPr/>
+                    <a:lstStyle/>
+                    <a:p>
+                      <a:pPr algn="ctr">
+                        <a:defRPr sz="1200" b="0">
+                          <a:solidFill>
+                            <a:srgbClr val="333333"/>
+                          </a:solidFill>
+                          <a:latin typeface="Calibri"/>
+                        </a:defRPr>
+                      </a:pPr>
+                      <a:r>
+                        <a:t>5</a:t>
+                      </a:r>
+                    </a:p>
+                  </a:txBody>
+                  <a:tcPr>
+                    <a:solidFill>
+                      <a:srgbClr val="FFFFFF"/>
+                    </a:solidFill>
+                  </a:tcPr>
+                </a:tc>
+                <a:tc>
+                  <a:txBody>
+                    <a:bodyPr/>
+                    <a:lstStyle/>
+                    <a:p>
+                      <a:pPr algn="ctr">
+                        <a:defRPr sz="1200" b="0">
+                          <a:solidFill>
+                            <a:srgbClr val="333333"/>
+                          </a:solidFill>
+                          <a:latin typeface="Calibri"/>
+                        </a:defRPr>
+                      </a:pPr>
+                      <a:r>
+                        <a:t>CAND_0044222</a:t>
+                      </a:r>
+                    </a:p>
+                  </a:txBody>
+                  <a:tcPr>
+                    <a:solidFill>
+                      <a:srgbClr val="FFFFFF"/>
+                    </a:solidFill>
+                  </a:tcPr>
+                </a:tc>
+                <a:tc>
+                  <a:txBody>
+                    <a:bodyPr/>
+                    <a:lstStyle/>
+                    <a:p>
+                      <a:pPr algn="ctr">
+                        <a:defRPr sz="1200" b="0">
+                          <a:solidFill>
+                            <a:srgbClr val="333333"/>
+                          </a:solidFill>
+                          <a:latin typeface="Calibri"/>
+                        </a:defRPr>
+                      </a:pPr>
+                      <a:r>
+                        <a:t>PolicyBazaar</a:t>
+                      </a:r>
+                    </a:p>
+                  </a:txBody>
+                  <a:tcPr>
+                    <a:solidFill>
+                      <a:srgbClr val="FFFFFF"/>
+                    </a:solidFill>
+                  </a:tcPr>
+                </a:tc>
+                <a:tc>
+                  <a:txBody>
+                    <a:bodyPr/>
+                    <a:lstStyle/>
+                    <a:p>
+                      <a:pPr algn="ctr">
+                        <a:defRPr sz="1200" b="0">
+                          <a:solidFill>
+                            <a:srgbClr val="333333"/>
+                          </a:solidFill>
+                          <a:latin typeface="Calibri"/>
+                        </a:defRPr>
+                      </a:pPr>
+                      <a:r>
+                        <a:t>0.8413</a:t>
+                      </a:r>
+                    </a:p>
+                  </a:txBody>
+                  <a:tcPr>
+                    <a:solidFill>
+                      <a:srgbClr val="FFFFFF"/>
+                    </a:solidFill>
+                  </a:tcPr>
+                </a:tc>
+                <a:tc>
+                  <a:txBody>
+                    <a:bodyPr/>
+                    <a:lstStyle/>
+                    <a:p>
+                      <a:pPr algn="ctr">
+                        <a:defRPr sz="1200" b="0">
+                          <a:solidFill>
+                            <a:srgbClr val="333333"/>
+                          </a:solidFill>
+                          <a:latin typeface="Calibri"/>
+                        </a:defRPr>
+                      </a:pPr>
+                      <a:r>
+                        <a:t>AI Engineer</a:t>
+                      </a:r>
+                    </a:p>
+                  </a:txBody>
+                  <a:tcPr>
+                    <a:solidFill>
+                      <a:srgbClr val="FFFFFF"/>
+                    </a:solidFill>
+                  </a:tcPr>
+                </a:tc>
+              </a:tr>
+              <a:tr h="232756">
+                <a:tc>
+                  <a:txBody>
+                    <a:bodyPr/>
+                    <a:lstStyle/>
+                    <a:p>
+                      <a:pPr algn="ctr">
+                        <a:defRPr sz="1200" b="0">
+                          <a:solidFill>
+                            <a:srgbClr val="333333"/>
+                          </a:solidFill>
+                          <a:latin typeface="Calibri"/>
+                        </a:defRPr>
+                      </a:pPr>
+                      <a:r>
+                        <a:t>6</a:t>
+                      </a:r>
+                    </a:p>
+                  </a:txBody>
+                  <a:tcPr>
+                    <a:solidFill>
+                      <a:srgbClr val="F0F4F8"/>
+                    </a:solidFill>
+                  </a:tcPr>
+                </a:tc>
+                <a:tc>
+                  <a:txBody>
+                    <a:bodyPr/>
+                    <a:lstStyle/>
+                    <a:p>
+                      <a:pPr algn="ctr">
+                        <a:defRPr sz="1200" b="0">
+                          <a:solidFill>
+                            <a:srgbClr val="333333"/>
+                          </a:solidFill>
+                          <a:latin typeface="Calibri"/>
+                        </a:defRPr>
+                      </a:pPr>
+                      <a:r>
+                        <a:t>CAND_0049538</a:t>
+                      </a:r>
+                    </a:p>
+                  </a:txBody>
+                  <a:tcPr>
+                    <a:solidFill>
+                      <a:srgbClr val="F0F4F8"/>
+                    </a:solidFill>
+                  </a:tcPr>
+                </a:tc>
+                <a:tc>
+                  <a:txBody>
+                    <a:bodyPr/>
+                    <a:lstStyle/>
+                    <a:p>
+                      <a:pPr algn="ctr">
+                        <a:defRPr sz="1200" b="0">
+                          <a:solidFill>
+                            <a:srgbClr val="333333"/>
+                          </a:solidFill>
+                          <a:latin typeface="Calibri"/>
+                        </a:defRPr>
+                      </a:pPr>
+                      <a:r>
+                        <a:t>Saarthi.ai</a:t>
+                      </a:r>
+                    </a:p>
+                  </a:txBody>
+                  <a:tcPr>
+                    <a:solidFill>
+                      <a:srgbClr val="F0F4F8"/>
+                    </a:solidFill>
+                  </a:tcPr>
+                </a:tc>
+                <a:tc>
+                  <a:txBody>
+                    <a:bodyPr/>
+                    <a:lstStyle/>
+                    <a:p>
+                      <a:pPr algn="ctr">
+                        <a:defRPr sz="1200" b="0">
+                          <a:solidFill>
+                            <a:srgbClr val="333333"/>
+                          </a:solidFill>
+                          <a:latin typeface="Calibri"/>
+                        </a:defRPr>
+                      </a:pPr>
+                      <a:r>
+                        <a:t>0.8365</a:t>
+                      </a:r>
+                    </a:p>
+                  </a:txBody>
+                  <a:tcPr>
+                    <a:solidFill>
+                      <a:srgbClr val="F0F4F8"/>
+                    </a:solidFill>
+                  </a:tcPr>
+                </a:tc>
+                <a:tc>
+                  <a:txBody>
+                    <a:bodyPr/>
+                    <a:lstStyle/>
+                    <a:p>
+                      <a:pPr algn="ctr">
+                        <a:defRPr sz="1200" b="0">
+                          <a:solidFill>
+                            <a:srgbClr val="333333"/>
+                          </a:solidFill>
+                          <a:latin typeface="Calibri"/>
+                        </a:defRPr>
+                      </a:pPr>
+                      <a:r>
+                        <a:t>Applied ML Engineer</a:t>
+                      </a:r>
+                    </a:p>
+                  </a:txBody>
+                  <a:tcPr>
+                    <a:solidFill>
+                      <a:srgbClr val="F0F4F8"/>
+                    </a:solidFill>
+                  </a:tcPr>
+                </a:tc>
+              </a:tr>
+              <a:tr h="232756">
+                <a:tc>
+                  <a:txBody>
+                    <a:bodyPr/>
+                    <a:lstStyle/>
+                    <a:p>
+                      <a:pPr algn="ctr">
+                        <a:defRPr sz="1200" b="0">
+                          <a:solidFill>
+                            <a:srgbClr val="333333"/>
+                          </a:solidFill>
+                          <a:latin typeface="Calibri"/>
+                        </a:defRPr>
+                      </a:pPr>
+                      <a:r>
+                        <a:t>7</a:t>
+                      </a:r>
+                    </a:p>
+                  </a:txBody>
+                  <a:tcPr>
+                    <a:solidFill>
+                      <a:srgbClr val="FFFFFF"/>
+                    </a:solidFill>
+                  </a:tcPr>
+                </a:tc>
+                <a:tc>
+                  <a:txBody>
+                    <a:bodyPr/>
+                    <a:lstStyle/>
+                    <a:p>
+                      <a:pPr algn="ctr">
+                        <a:defRPr sz="1200" b="0">
+                          <a:solidFill>
+                            <a:srgbClr val="333333"/>
+                          </a:solidFill>
+                          <a:latin typeface="Calibri"/>
+                        </a:defRPr>
+                      </a:pPr>
+                      <a:r>
+                        <a:t>CAND_0071974</a:t>
+                      </a:r>
+                    </a:p>
+                  </a:txBody>
+                  <a:tcPr>
+                    <a:solidFill>
+                      <a:srgbClr val="FFFFFF"/>
+                    </a:solidFill>
+                  </a:tcPr>
+                </a:tc>
+                <a:tc>
+                  <a:txBody>
+                    <a:bodyPr/>
+                    <a:lstStyle/>
+                    <a:p>
+                      <a:pPr algn="ctr">
+                        <a:defRPr sz="1200" b="0">
+                          <a:solidFill>
+                            <a:srgbClr val="333333"/>
+                          </a:solidFill>
+                          <a:latin typeface="Calibri"/>
+                        </a:defRPr>
+                      </a:pPr>
+                      <a:r>
+                        <a:t>Netflix</a:t>
+                      </a:r>
+                    </a:p>
+                  </a:txBody>
+                  <a:tcPr>
+                    <a:solidFill>
+                      <a:srgbClr val="FFFFFF"/>
+                    </a:solidFill>
+                  </a:tcPr>
+                </a:tc>
+                <a:tc>
+                  <a:txBody>
+                    <a:bodyPr/>
+                    <a:lstStyle/>
+                    <a:p>
+                      <a:pPr algn="ctr">
+                        <a:defRPr sz="1200" b="0">
+                          <a:solidFill>
+                            <a:srgbClr val="333333"/>
+                          </a:solidFill>
+                          <a:latin typeface="Calibri"/>
+                        </a:defRPr>
+                      </a:pPr>
+                      <a:r>
+                        <a:t>0.8301</a:t>
+                      </a:r>
+                    </a:p>
+                  </a:txBody>
+                  <a:tcPr>
+                    <a:solidFill>
+                      <a:srgbClr val="FFFFFF"/>
+                    </a:solidFill>
+                  </a:tcPr>
+                </a:tc>
+                <a:tc>
+                  <a:txBody>
+                    <a:bodyPr/>
+                    <a:lstStyle/>
+                    <a:p>
+                      <a:pPr algn="ctr">
+                        <a:defRPr sz="1200" b="0">
+                          <a:solidFill>
+                            <a:srgbClr val="333333"/>
+                          </a:solidFill>
+                          <a:latin typeface="Calibri"/>
+                        </a:defRPr>
+                      </a:pPr>
+                      <a:r>
+                        <a:t>Senior AI Engineer</a:t>
+                      </a:r>
+                    </a:p>
+                  </a:txBody>
+                  <a:tcPr>
+                    <a:solidFill>
+                      <a:srgbClr val="FFFFFF"/>
+                    </a:solidFill>
+                  </a:tcPr>
+                </a:tc>
+              </a:tr>
+              <a:tr h="232756">
+                <a:tc>
+                  <a:txBody>
+                    <a:bodyPr/>
+                    <a:lstStyle/>
+                    <a:p>
+                      <a:pPr algn="ctr">
+                        <a:defRPr sz="1200" b="0">
+                          <a:solidFill>
+                            <a:srgbClr val="333333"/>
+                          </a:solidFill>
+                          <a:latin typeface="Calibri"/>
+                        </a:defRPr>
+                      </a:pPr>
+                      <a:r>
+                        <a:t>8</a:t>
+                      </a:r>
+                    </a:p>
+                  </a:txBody>
+                  <a:tcPr>
+                    <a:solidFill>
+                      <a:srgbClr val="F0F4F8"/>
+                    </a:solidFill>
+                  </a:tcPr>
+                </a:tc>
+                <a:tc>
+                  <a:txBody>
+                    <a:bodyPr/>
+                    <a:lstStyle/>
+                    <a:p>
+                      <a:pPr algn="ctr">
+                        <a:defRPr sz="1200" b="0">
+                          <a:solidFill>
+                            <a:srgbClr val="333333"/>
+                          </a:solidFill>
+                          <a:latin typeface="Calibri"/>
+                        </a:defRPr>
+                      </a:pPr>
+                      <a:r>
+                        <a:t>CAND_0062247</a:t>
+                      </a:r>
+                    </a:p>
+                  </a:txBody>
+                  <a:tcPr>
+                    <a:solidFill>
+                      <a:srgbClr val="F0F4F8"/>
+                    </a:solidFill>
+                  </a:tcPr>
+                </a:tc>
+                <a:tc>
+                  <a:txBody>
+                    <a:bodyPr/>
+                    <a:lstStyle/>
+                    <a:p>
+                      <a:pPr algn="ctr">
+                        <a:defRPr sz="1200" b="0">
+                          <a:solidFill>
+                            <a:srgbClr val="333333"/>
+                          </a:solidFill>
+                          <a:latin typeface="Calibri"/>
+                        </a:defRPr>
+                      </a:pPr>
+                      <a:r>
+                        <a:t>Google</a:t>
+                      </a:r>
+                    </a:p>
+                  </a:txBody>
+                  <a:tcPr>
+                    <a:solidFill>
+                      <a:srgbClr val="F0F4F8"/>
+                    </a:solidFill>
+                  </a:tcPr>
+                </a:tc>
+                <a:tc>
+                  <a:txBody>
+                    <a:bodyPr/>
+                    <a:lstStyle/>
+                    <a:p>
+                      <a:pPr algn="ctr">
+                        <a:defRPr sz="1200" b="0">
+                          <a:solidFill>
+                            <a:srgbClr val="333333"/>
+                          </a:solidFill>
+                          <a:latin typeface="Calibri"/>
+                        </a:defRPr>
+                      </a:pPr>
+                      <a:r>
+                        <a:t>0.8244</a:t>
+                      </a:r>
+                    </a:p>
+                  </a:txBody>
+                  <a:tcPr>
+                    <a:solidFill>
+                      <a:srgbClr val="F0F4F8"/>
+                    </a:solidFill>
+                  </a:tcPr>
+                </a:tc>
+                <a:tc>
+                  <a:txBody>
+                    <a:bodyPr/>
+                    <a:lstStyle/>
+                    <a:p>
+                      <a:pPr algn="ctr">
+                        <a:defRPr sz="1200" b="0">
+                          <a:solidFill>
+                            <a:srgbClr val="333333"/>
+                          </a:solidFill>
+                          <a:latin typeface="Calibri"/>
+                        </a:defRPr>
+                      </a:pPr>
+                      <a:r>
+                        <a:t>AI Engineer</a:t>
+                      </a:r>
+                    </a:p>
+                  </a:txBody>
+                  <a:tcPr>
+                    <a:solidFill>
+                      <a:srgbClr val="F0F4F8"/>
+                    </a:solidFill>
+                  </a:tcPr>
+                </a:tc>
+              </a:tr>
+              <a:tr h="232756">
+                <a:tc>
+                  <a:txBody>
+                    <a:bodyPr/>
+                    <a:lstStyle/>
+                    <a:p>
+                      <a:pPr algn="ctr">
+                        <a:defRPr sz="1200" b="0">
+                          <a:solidFill>
+                            <a:srgbClr val="333333"/>
+                          </a:solidFill>
+                          <a:latin typeface="Calibri"/>
+                        </a:defRPr>
+                      </a:pPr>
+                      <a:r>
+                        <a:t>9</a:t>
+                      </a:r>
+                    </a:p>
+                  </a:txBody>
+                  <a:tcPr>
+                    <a:solidFill>
+                      <a:srgbClr val="FFFFFF"/>
+                    </a:solidFill>
+                  </a:tcPr>
+                </a:tc>
+                <a:tc>
+                  <a:txBody>
+                    <a:bodyPr/>
+                    <a:lstStyle/>
+                    <a:p>
+                      <a:pPr algn="ctr">
+                        <a:defRPr sz="1200" b="0">
+                          <a:solidFill>
+                            <a:srgbClr val="333333"/>
+                          </a:solidFill>
+                          <a:latin typeface="Calibri"/>
+                        </a:defRPr>
+                      </a:pPr>
+                      <a:r>
+                        <a:t>CAND_0030031</a:t>
+                      </a:r>
+                    </a:p>
+                  </a:txBody>
+                  <a:tcPr>
+                    <a:solidFill>
+                      <a:srgbClr val="FFFFFF"/>
+                    </a:solidFill>
+                  </a:tcPr>
+                </a:tc>
+                <a:tc>
+                  <a:txBody>
+                    <a:bodyPr/>
+                    <a:lstStyle/>
+                    <a:p>
+                      <a:pPr algn="ctr">
+                        <a:defRPr sz="1200" b="0">
+                          <a:solidFill>
+                            <a:srgbClr val="333333"/>
+                          </a:solidFill>
+                          <a:latin typeface="Calibri"/>
+                        </a:defRPr>
+                      </a:pPr>
+                      <a:r>
+                        <a:t>Microsoft</a:t>
+                      </a:r>
+                    </a:p>
+                  </a:txBody>
+                  <a:tcPr>
+                    <a:solidFill>
+                      <a:srgbClr val="FFFFFF"/>
+                    </a:solidFill>
+                  </a:tcPr>
+                </a:tc>
+                <a:tc>
+                  <a:txBody>
+                    <a:bodyPr/>
+                    <a:lstStyle/>
+                    <a:p>
+                      <a:pPr algn="ctr">
+                        <a:defRPr sz="1200" b="0">
+                          <a:solidFill>
+                            <a:srgbClr val="333333"/>
+                          </a:solidFill>
+                          <a:latin typeface="Calibri"/>
+                        </a:defRPr>
+                      </a:pPr>
+                      <a:r>
+                        <a:t>0.8152</a:t>
+                      </a:r>
+                    </a:p>
+                  </a:txBody>
+                  <a:tcPr>
+                    <a:solidFill>
+                      <a:srgbClr val="FFFFFF"/>
+                    </a:solidFill>
+                  </a:tcPr>
+                </a:tc>
+                <a:tc>
+                  <a:txBody>
+                    <a:bodyPr/>
+                    <a:lstStyle/>
+                    <a:p>
+                      <a:pPr algn="ctr">
+                        <a:defRPr sz="1200" b="0">
+                          <a:solidFill>
+                            <a:srgbClr val="333333"/>
+                          </a:solidFill>
+                          <a:latin typeface="Calibri"/>
+                        </a:defRPr>
+                      </a:pPr>
+                      <a:r>
+                        <a:t>AI Engineer</a:t>
+                      </a:r>
+                    </a:p>
+                  </a:txBody>
+                  <a:tcPr>
+                    <a:solidFill>
+                      <a:srgbClr val="FFFFFF"/>
+                    </a:solidFill>
+                  </a:tcPr>
+                </a:tc>
+              </a:tr>
+              <a:tr h="232760">
+                <a:tc>
+                  <a:txBody>
+                    <a:bodyPr/>
+                    <a:lstStyle/>
+                    <a:p>
+                      <a:pPr algn="ctr">
+                        <a:defRPr sz="1200" b="0">
+                          <a:solidFill>
+                            <a:srgbClr val="333333"/>
+                          </a:solidFill>
+                          <a:latin typeface="Calibri"/>
+                        </a:defRPr>
+                      </a:pPr>
+                      <a:r>
+                        <a:t>10</a:t>
+                      </a:r>
+                    </a:p>
+                  </a:txBody>
+                  <a:tcPr>
+                    <a:solidFill>
+                      <a:srgbClr val="F0F4F8"/>
+                    </a:solidFill>
+                  </a:tcPr>
+                </a:tc>
+                <a:tc>
+                  <a:txBody>
+                    <a:bodyPr/>
+                    <a:lstStyle/>
+                    <a:p>
+                      <a:pPr algn="ctr">
+                        <a:defRPr sz="1200" b="0">
+                          <a:solidFill>
+                            <a:srgbClr val="333333"/>
+                          </a:solidFill>
+                          <a:latin typeface="Calibri"/>
+                        </a:defRPr>
+                      </a:pPr>
+                      <a:r>
+                        <a:t>CAND_0081846</a:t>
+                      </a:r>
+                    </a:p>
+                  </a:txBody>
+                  <a:tcPr>
+                    <a:solidFill>
+                      <a:srgbClr val="F0F4F8"/>
+                    </a:solidFill>
+                  </a:tcPr>
+                </a:tc>
+                <a:tc>
+                  <a:txBody>
+                    <a:bodyPr/>
+                    <a:lstStyle/>
+                    <a:p>
+                      <a:pPr algn="ctr">
+                        <a:defRPr sz="1200" b="0">
+                          <a:solidFill>
+                            <a:srgbClr val="333333"/>
+                          </a:solidFill>
+                          <a:latin typeface="Calibri"/>
+                        </a:defRPr>
+                      </a:pPr>
+                      <a:r>
+                        <a:t>Razorpay</a:t>
+                      </a:r>
+                    </a:p>
+                  </a:txBody>
+                  <a:tcPr>
+                    <a:solidFill>
+                      <a:srgbClr val="F0F4F8"/>
+                    </a:solidFill>
+                  </a:tcPr>
+                </a:tc>
+                <a:tc>
+                  <a:txBody>
+                    <a:bodyPr/>
+                    <a:lstStyle/>
+                    <a:p>
+                      <a:pPr algn="ctr">
+                        <a:defRPr sz="1200" b="0">
+                          <a:solidFill>
+                            <a:srgbClr val="333333"/>
+                          </a:solidFill>
+                          <a:latin typeface="Calibri"/>
+                        </a:defRPr>
+                      </a:pPr>
+                      <a:r>
+                        <a:t>0.8128</a:t>
+                      </a:r>
+                    </a:p>
+                  </a:txBody>
+                  <a:tcPr>
+                    <a:solidFill>
+                      <a:srgbClr val="F0F4F8"/>
+                    </a:solidFill>
+                  </a:tcPr>
+                </a:tc>
+                <a:tc>
+                  <a:txBody>
+                    <a:bodyPr/>
+                    <a:lstStyle/>
+                    <a:p>
+                      <a:pPr algn="ctr">
+                        <a:defRPr sz="1200" b="0">
+                          <a:solidFill>
+                            <a:srgbClr val="333333"/>
+                          </a:solidFill>
+                          <a:latin typeface="Calibri"/>
+                        </a:defRPr>
+                      </a:pPr>
+                      <a:r>
+                        <a:t>Lead AI Engineer</a:t>
+                      </a:r>
+                    </a:p>
+                  </a:txBody>
+                  <a:tcPr>
+                    <a:solidFill>
+                      <a:srgbClr val="F0F4F8"/>
+                    </a:solidFill>
+                  </a:tcPr>
+                </a:tc>
+              </a:tr>
+            </a:tbl>
+          </a:graphicData>
+        </a:graphic>
+      </p:graphicFrame>
+    </p:spTree>
+  </p:cSld>
+  <p:clrMapOvr>
+    <a:masterClrMapping/>
+  </p:clrMapOvr>
+</p:sld>
+</file>
+
+<file path=ppt/slides/slide8.xml><?xml version="1.0" encoding="utf-8"?>
+<p:sld xmlns:a="http://schemas.openxmlformats.org/drawingml/2006/main" xmlns:p="http://schemas.openxmlformats.org/presentationml/2006/main" xmlns:r="http://schemas.openxmlformats.org/officeDocument/2006/relationships">
+  <p:cSld>
+    <p:bg>
+      <p:bgPr>
+        <a:solidFill>
+          <a:srgbClr val="FFFFFF"/>
+        </a:solidFill>
+        <a:effectLst/>
+      </p:bgPr>
+    </p:bg>
+    <p:spTree>
+      <p:nvGrpSpPr>
+        <p:cNvPr id="1" name=""/>
+        <p:cNvGrpSpPr/>
+        <p:nvPr/>
+      </p:nvGrpSpPr>
+      <p:grpSpPr/>
+      <p:sp>
+        <p:nvSpPr>
+          <p:cNvPr id="2" name="Rectangle 1"/>
+          <p:cNvSpPr/>
+          <p:nvPr/>
+        </p:nvSpPr>
+        <p:spPr>
+          <a:xfrm>
+            <a:off x="0" y="0"/>
+            <a:ext cx="12191695" cy="914400"/>
+          </a:xfrm>
+          <a:prstGeom prst="rect">
+            <a:avLst/>
+          </a:prstGeom>
+          <a:solidFill>
+            <a:srgbClr val="1A3C6E"/>
+          </a:solidFill>
+          <a:ln>
+            <a:noFill/>
+          </a:ln>
+        </p:spPr>
+        <p:style>
+          <a:lnRef idx="1">
+            <a:schemeClr val="accent1"/>
+          </a:lnRef>
+          <a:fillRef idx="3">
+            <a:schemeClr val="accent1"/>
+          </a:fillRef>
+          <a:effectRef idx="2">
+            <a:schemeClr val="accent1"/>
+          </a:effectRef>
+          <a:fontRef idx="minor">
+            <a:schemeClr val="lt1"/>
+          </a:fontRef>
+        </p:style>
+        <p:txBody>
+          <a:bodyPr rtlCol="0" anchor="ctr"/>
+          <a:lstStyle/>
+          <a:p>
+            <a:pPr algn="ctr"/>
+          </a:p>
+        </p:txBody>
+      </p:sp>
+      <p:sp>
+        <p:nvSpPr>
+          <p:cNvPr id="3" name="TextBox 2"/>
+          <p:cNvSpPr txBox="1"/>
+          <p:nvPr/>
+        </p:nvSpPr>
+        <p:spPr>
+          <a:xfrm>
+            <a:off x="457200" y="182880"/>
+            <a:ext cx="10972800" cy="548640"/>
+          </a:xfrm>
+          <a:prstGeom prst="rect">
+            <a:avLst/>
+          </a:prstGeom>
+          <a:noFill/>
+        </p:spPr>
+        <p:txBody>
+          <a:bodyPr wrap="square">
+            <a:spAutoFit/>
+          </a:bodyPr>
+          <a:lstStyle/>
+          <a:p>
+            <a:pPr algn="l">
+              <a:defRPr sz="3200" b="1">
+                <a:solidFill>
+                  <a:srgbClr val="FFFFFF"/>
+                </a:solidFill>
+                <a:latin typeface="Calibri"/>
+              </a:defRPr>
+            </a:pPr>
+            <a:r>
+              <a:t>Tech Stack &amp; Reproducibility</a:t>
+            </a:r>
+          </a:p>
+        </p:txBody>
+      </p:sp>
+      <p:sp>
+        <p:nvSpPr>
+          <p:cNvPr id="4" name="TextBox 3"/>
+          <p:cNvSpPr txBox="1"/>
+          <p:nvPr/>
+        </p:nvSpPr>
+        <p:spPr>
+          <a:xfrm>
+            <a:off x="640080" y="1188720"/>
+            <a:ext cx="5029200" cy="365760"/>
+          </a:xfrm>
+          <a:prstGeom prst="rect">
+            <a:avLst/>
+          </a:prstGeom>
+          <a:noFill/>
+        </p:spPr>
+        <p:txBody>
+          <a:bodyPr wrap="square">
+            <a:spAutoFit/>
+          </a:bodyPr>
+          <a:lstStyle/>
+          <a:p>
+            <a:pPr algn="l">
+              <a:defRPr sz="2000" b="1">
+                <a:solidFill>
+                  <a:srgbClr val="2D6BC4"/>
+                </a:solidFill>
+                <a:latin typeface="Calibri"/>
+              </a:defRPr>
+            </a:pPr>
+            <a:r>
+              <a:t>Technology</a:t>
+            </a:r>
+          </a:p>
+        </p:txBody>
+      </p:sp>
+      <p:sp>
+        <p:nvSpPr>
+          <p:cNvPr id="5" name="TextBox 4"/>
+          <p:cNvSpPr txBox="1"/>
+          <p:nvPr/>
+        </p:nvSpPr>
+        <p:spPr>
+          <a:xfrm>
+            <a:off x="640080" y="1645920"/>
+            <a:ext cx="5029200" cy="3657600"/>
+          </a:xfrm>
+          <a:prstGeom prst="rect">
+            <a:avLst/>
+          </a:prstGeom>
+          <a:noFill/>
+        </p:spPr>
+        <p:txBody>
+          <a:bodyPr wrap="square">
+            <a:spAutoFit/>
+          </a:bodyPr>
+          <a:lstStyle/>
           <a:p>
             <a:pPr>
-              <a:defRPr sz="1800"/>
+              <a:spcAft>
+                <a:spcPts val="600"/>
+              </a:spcAft>
+              <a:defRPr sz="1500">
+                <a:solidFill>
+                  <a:srgbClr val="333333"/>
+                </a:solidFill>
+                <a:latin typeface="Calibri"/>
+              </a:defRPr>
             </a:pPr>
             <a:r>
-              <a:t>Honeypots in top-100: 0</a:t>
+              <a:t>Python 3.13 — all logic, no external ranking services</a:t>
             </a:r>
           </a:p>
           <a:p>
             <a:pPr>
-              <a:defRPr sz="1800"/>
+              <a:spcAft>
+                <a:spcPts val="600"/>
+              </a:spcAft>
+              <a:defRPr sz="1500">
+                <a:solidFill>
+                  <a:srgbClr val="333333"/>
+                </a:solidFill>
+                <a:latin typeface="Calibri"/>
+              </a:defRPr>
             </a:pPr>
             <a:r>
-              <a:t>Unique scores: 91/100 (9 tied pairs, resolved by candidate_id)</a:t>
+              <a:t>sentence-transformers (all-MiniLM-L6-v2, 384-dim)</a:t>
             </a:r>
           </a:p>
           <a:p>
             <a:pPr>
-              <a:defRPr sz="1800"/>
+              <a:spcAft>
+                <a:spcPts val="600"/>
+              </a:spcAft>
+              <a:defRPr sz="1500">
+                <a:solidFill>
+                  <a:srgbClr val="333333"/>
+                </a:solidFill>
+                <a:latin typeface="Calibri"/>
+              </a:defRPr>
             </a:pPr>
+            <a:r>
+              <a:t>FAISS CPU (IndexFlatIP — inner product)</a:t>
+            </a:r>
           </a:p>
           <a:p>
             <a:pPr>
-              <a:defRPr sz="1800"/>
+              <a:spcAft>
+                <a:spcPts val="600"/>
+              </a:spcAft>
+              <a:defRPr sz="1500">
+                <a:solidFill>
+                  <a:srgbClr val="333333"/>
+                </a:solidFill>
+                <a:latin typeface="Calibri"/>
+              </a:defRPr>
             </a:pPr>
             <a:r>
-              <a:t>Top candidates: Senior AI/ML engineers from product companies</a:t>
+              <a:t>NumPy, pandas, scikit-learn, python-dateutil</a:t>
             </a:r>
           </a:p>
           <a:p>
             <a:pPr>
-              <a:defRPr sz="1800"/>
+              <a:spcAft>
+                <a:spcPts val="600"/>
+              </a:spcAft>
+              <a:defRPr sz="1500">
+                <a:solidFill>
+                  <a:srgbClr val="333333"/>
+                </a:solidFill>
+                <a:latin typeface="Calibri"/>
+              </a:defRPr>
             </a:pPr>
             <a:r>
-              <a:t>(Rephrase.ai, LinkedIn, Krutrim, upGrad, Haptik, CRED, Ola, Google)</a:t>
+              <a:t>CSV output — no hidden or manual steps</a:t>
+            </a:r>
+          </a:p>
+          <a:p>
+            <a:pPr>
+              <a:spcAft>
+                <a:spcPts val="600"/>
+              </a:spcAft>
+              <a:defRPr sz="1500">
+                <a:solidFill>
+                  <a:srgbClr val="333333"/>
+                </a:solidFill>
+                <a:latin typeface="Calibri"/>
+              </a:defRPr>
+            </a:pPr>
+            <a:r>
+              <a:t>Windows 11, AMD Ryzen 7 7840U, 16 GB RAM</a:t>
+            </a:r>
+          </a:p>
+        </p:txBody>
+      </p:sp>
+      <p:sp>
+        <p:nvSpPr>
+          <p:cNvPr id="6" name="TextBox 5"/>
+          <p:cNvSpPr txBox="1"/>
+          <p:nvPr/>
+        </p:nvSpPr>
+        <p:spPr>
+          <a:xfrm>
+            <a:off x="6400800" y="1188720"/>
+            <a:ext cx="5029200" cy="365760"/>
+          </a:xfrm>
+          <a:prstGeom prst="rect">
+            <a:avLst/>
+          </a:prstGeom>
+          <a:noFill/>
+        </p:spPr>
+        <p:txBody>
+          <a:bodyPr wrap="square">
+            <a:spAutoFit/>
+          </a:bodyPr>
+          <a:lstStyle/>
+          <a:p>
+            <a:pPr algn="l">
+              <a:defRPr sz="2000" b="1">
+                <a:solidFill>
+                  <a:srgbClr val="2D6BC4"/>
+                </a:solidFill>
+                <a:latin typeface="Calibri"/>
+              </a:defRPr>
+            </a:pPr>
+            <a:r>
+              <a:t>Reproduce</a:t>
+            </a:r>
+          </a:p>
+        </p:txBody>
+      </p:sp>
+      <p:sp>
+        <p:nvSpPr>
+          <p:cNvPr id="7" name="TextBox 6"/>
+          <p:cNvSpPr txBox="1"/>
+          <p:nvPr/>
+        </p:nvSpPr>
+        <p:spPr>
+          <a:xfrm>
+            <a:off x="6400800" y="1645920"/>
+            <a:ext cx="5029200" cy="3657600"/>
+          </a:xfrm>
+          <a:prstGeom prst="rect">
+            <a:avLst/>
+          </a:prstGeom>
+          <a:noFill/>
+        </p:spPr>
+        <p:txBody>
+          <a:bodyPr wrap="square">
+            <a:spAutoFit/>
+          </a:bodyPr>
+          <a:lstStyle/>
+          <a:p>
+            <a:pPr>
+              <a:spcAft>
+                <a:spcPts val="600"/>
+              </a:spcAft>
+              <a:defRPr sz="1500">
+                <a:solidFill>
+                  <a:srgbClr val="333333"/>
+                </a:solidFill>
+                <a:latin typeface="Calibri"/>
+              </a:defRPr>
+            </a:pPr>
+            <a:r>
+              <a:t>1. git clone https://github.com/shivv23/candidate-ranker-system</a:t>
+            </a:r>
+          </a:p>
+          <a:p>
+            <a:pPr>
+              <a:spcAft>
+                <a:spcPts val="600"/>
+              </a:spcAft>
+              <a:defRPr sz="1500">
+                <a:solidFill>
+                  <a:srgbClr val="333333"/>
+                </a:solidFill>
+                <a:latin typeface="Calibri"/>
+              </a:defRPr>
+            </a:pPr>
+            <a:r>
+              <a:t>2. pip install -r requirements.txt</a:t>
+            </a:r>
+          </a:p>
+          <a:p>
+            <a:pPr>
+              <a:spcAft>
+                <a:spcPts val="600"/>
+              </a:spcAft>
+              <a:defRPr sz="1500">
+                <a:solidFill>
+                  <a:srgbClr val="333333"/>
+                </a:solidFill>
+                <a:latin typeface="Calibri"/>
+              </a:defRPr>
+            </a:pPr>
+            <a:r>
+              <a:t>3. Place candidates.jsonl in data/raw/</a:t>
+            </a:r>
+          </a:p>
+          <a:p>
+            <a:pPr>
+              <a:spcAft>
+                <a:spcPts val="600"/>
+              </a:spcAft>
+              <a:defRPr sz="1500">
+                <a:solidFill>
+                  <a:srgbClr val="333333"/>
+                </a:solidFill>
+                <a:latin typeface="Calibri"/>
+              </a:defRPr>
+            </a:pPr>
+            <a:r>
+              <a:t>4. python precompute.py (~14 min, one-time)</a:t>
+            </a:r>
+          </a:p>
+          <a:p>
+            <a:pPr>
+              <a:spcAft>
+                <a:spcPts val="600"/>
+              </a:spcAft>
+              <a:defRPr sz="1500">
+                <a:solidFill>
+                  <a:srgbClr val="333333"/>
+                </a:solidFill>
+                <a:latin typeface="Calibri"/>
+              </a:defRPr>
+            </a:pPr>
+            <a:r>
+              <a:t>5. python rank.py (14s, ≤5 min budget)</a:t>
+            </a:r>
+          </a:p>
+          <a:p>
+            <a:pPr>
+              <a:spcAft>
+                <a:spcPts val="600"/>
+              </a:spcAft>
+              <a:defRPr sz="1500">
+                <a:solidFill>
+                  <a:srgbClr val="333333"/>
+                </a:solidFill>
+                <a:latin typeface="Calibri"/>
+              </a:defRPr>
+            </a:pPr>
+            <a:r>
+              <a:t>6. python data/validate_submission.py data/output/submission.csv</a:t>
+            </a:r>
+          </a:p>
+          <a:p>
+            <a:pPr>
+              <a:spcAft>
+                <a:spcPts val="600"/>
+              </a:spcAft>
+              <a:defRPr sz="1500">
+                <a:solidFill>
+                  <a:srgbClr val="333333"/>
+                </a:solidFill>
+                <a:latin typeface="Calibri"/>
+              </a:defRPr>
+            </a:pPr>
+          </a:p>
+          <a:p>
+            <a:pPr>
+              <a:spcAft>
+                <a:spcPts val="600"/>
+              </a:spcAft>
+              <a:defRPr sz="1500">
+                <a:solidFill>
+                  <a:srgbClr val="333333"/>
+                </a:solidFill>
+                <a:latin typeface="Calibri"/>
+              </a:defRPr>
+            </a:pPr>
+            <a:r>
+              <a:t>Full validation output: PASS (format, scores, tie-breaks)</a:t>
+            </a:r>
+          </a:p>
+        </p:txBody>
+      </p:sp>
+    </p:spTree>
+  </p:cSld>
+  <p:clrMapOvr>
+    <a:masterClrMapping/>
+  </p:clrMapOvr>
+</p:sld>
+</file>
+
+<file path=ppt/slides/slide9.xml><?xml version="1.0" encoding="utf-8"?>
+<p:sld xmlns:a="http://schemas.openxmlformats.org/drawingml/2006/main" xmlns:p="http://schemas.openxmlformats.org/presentationml/2006/main" xmlns:r="http://schemas.openxmlformats.org/officeDocument/2006/relationships">
+  <p:cSld>
+    <p:bg>
+      <p:bgPr>
+        <a:solidFill>
+          <a:srgbClr val="0D1B2A"/>
+        </a:solidFill>
+        <a:effectLst/>
+      </p:bgPr>
+    </p:bg>
+    <p:spTree>
+      <p:nvGrpSpPr>
+        <p:cNvPr id="1" name=""/>
+        <p:cNvGrpSpPr/>
+        <p:nvPr/>
+      </p:nvGrpSpPr>
+      <p:grpSpPr/>
+      <p:sp>
+        <p:nvSpPr>
+          <p:cNvPr id="2" name="Rectangle 1"/>
+          <p:cNvSpPr/>
+          <p:nvPr/>
+        </p:nvSpPr>
+        <p:spPr>
+          <a:xfrm>
+            <a:off x="0" y="2743200"/>
+            <a:ext cx="12191695" cy="54864"/>
+          </a:xfrm>
+          <a:prstGeom prst="rect">
+            <a:avLst/>
+          </a:prstGeom>
+          <a:solidFill>
+            <a:srgbClr val="0096D6"/>
+          </a:solidFill>
+          <a:ln>
+            <a:noFill/>
+          </a:ln>
+        </p:spPr>
+        <p:style>
+          <a:lnRef idx="1">
+            <a:schemeClr val="accent1"/>
+          </a:lnRef>
+          <a:fillRef idx="3">
+            <a:schemeClr val="accent1"/>
+          </a:fillRef>
+          <a:effectRef idx="2">
+            <a:schemeClr val="accent1"/>
+          </a:effectRef>
+          <a:fontRef idx="minor">
+            <a:schemeClr val="lt1"/>
+          </a:fontRef>
+        </p:style>
+        <p:txBody>
+          <a:bodyPr rtlCol="0" anchor="ctr"/>
+          <a:lstStyle/>
+          <a:p>
+            <a:pPr algn="ctr"/>
+          </a:p>
+        </p:txBody>
+      </p:sp>
+      <p:sp>
+        <p:nvSpPr>
+          <p:cNvPr id="3" name="TextBox 2"/>
+          <p:cNvSpPr txBox="1"/>
+          <p:nvPr/>
+        </p:nvSpPr>
+        <p:spPr>
+          <a:xfrm>
+            <a:off x="914400" y="1371600"/>
+            <a:ext cx="10058400" cy="914400"/>
+          </a:xfrm>
+          <a:prstGeom prst="rect">
+            <a:avLst/>
+          </a:prstGeom>
+          <a:noFill/>
+        </p:spPr>
+        <p:txBody>
+          <a:bodyPr wrap="square">
+            <a:spAutoFit/>
+          </a:bodyPr>
+          <a:lstStyle/>
+          <a:p>
+            <a:pPr algn="ctr">
+              <a:defRPr sz="4400" b="1">
+                <a:solidFill>
+                  <a:srgbClr val="FFFFFF"/>
+                </a:solidFill>
+                <a:latin typeface="Calibri"/>
+              </a:defRPr>
+            </a:pPr>
+            <a:r>
+              <a:t>Thank You</a:t>
+            </a:r>
+          </a:p>
+        </p:txBody>
+      </p:sp>
+      <p:sp>
+        <p:nvSpPr>
+          <p:cNvPr id="4" name="TextBox 3"/>
+          <p:cNvSpPr txBox="1"/>
+          <p:nvPr/>
+        </p:nvSpPr>
+        <p:spPr>
+          <a:xfrm>
+            <a:off x="914400" y="3108960"/>
+            <a:ext cx="10058400" cy="457200"/>
+          </a:xfrm>
+          <a:prstGeom prst="rect">
+            <a:avLst/>
+          </a:prstGeom>
+          <a:noFill/>
+        </p:spPr>
+        <p:txBody>
+          <a:bodyPr wrap="square">
+            <a:spAutoFit/>
+          </a:bodyPr>
+          <a:lstStyle/>
+          <a:p>
+            <a:pPr algn="ctr">
+              <a:defRPr sz="2200" b="0">
+                <a:solidFill>
+                  <a:srgbClr val="0096D6"/>
+                </a:solidFill>
+                <a:latin typeface="Calibri"/>
+              </a:defRPr>
+            </a:pPr>
+            <a:r>
+              <a:t>shivv23 | Solo Participant</a:t>
+            </a:r>
+          </a:p>
+        </p:txBody>
+      </p:sp>
+      <p:sp>
+        <p:nvSpPr>
+          <p:cNvPr id="5" name="TextBox 4"/>
+          <p:cNvSpPr txBox="1"/>
+          <p:nvPr/>
+        </p:nvSpPr>
+        <p:spPr>
+          <a:xfrm>
+            <a:off x="914400" y="3840480"/>
+            <a:ext cx="10058400" cy="457200"/>
+          </a:xfrm>
+          <a:prstGeom prst="rect">
+            <a:avLst/>
+          </a:prstGeom>
+          <a:noFill/>
+        </p:spPr>
+        <p:txBody>
+          <a:bodyPr wrap="square">
+            <a:spAutoFit/>
+          </a:bodyPr>
+          <a:lstStyle/>
+          <a:p>
+            <a:pPr algn="ctr">
+              <a:defRPr sz="1600" b="0">
+                <a:solidFill>
+                  <a:srgbClr val="666666"/>
+                </a:solidFill>
+                <a:latin typeface="Calibri"/>
+              </a:defRPr>
+            </a:pPr>
+            <a:r>
+              <a:t>https://github.com/shivv23/candidate-ranker-system</a:t>
             </a:r>
           </a:p>
         </p:txBody>

</xml_diff>